<commit_message>
Update capsule image, remove PBE0
</commit_message>
<xml_diff>
--- a/Open-Scientific-Intelligence-Hackathon-2026/media/capsule_maker_video_20261022_223724.pptx
+++ b/Open-Scientific-Intelligence-Hackathon-2026/media/capsule_maker_video_20261022_223724.pptx
@@ -70,7 +70,16 @@
                 </a:solidFill>
                 <a:latin typeface="Aptos"/>
               </a:rPr>
-              <a:t>Click to move the slide</a:t>
+              <a:t>Click to move </a:t>
+            </a:r>
+            <a:r>
+              <a:rPr b="0" lang="en-GB" sz="1800" spc="-1" strike="noStrike">
+                <a:solidFill>
+                  <a:schemeClr val="dk1"/>
+                </a:solidFill>
+                <a:latin typeface="Aptos"/>
+              </a:rPr>
+              <a:t>the slide</a:t>
             </a:r>
             <a:endParaRPr b="0" lang="en-GB" sz="1800" spc="-1" strike="noStrike">
               <a:solidFill>
@@ -119,7 +128,16 @@
                 </a:solidFill>
                 <a:latin typeface="Arial"/>
               </a:rPr>
-              <a:t>Click to edit the notes format</a:t>
+              <a:t>Click to edit the notes </a:t>
+            </a:r>
+            <a:r>
+              <a:rPr b="0" lang="en-GB" sz="2000" spc="-1" strike="noStrike">
+                <a:solidFill>
+                  <a:srgbClr val="000000"/>
+                </a:solidFill>
+                <a:latin typeface="Arial"/>
+              </a:rPr>
+              <a:t>format</a:t>
             </a:r>
             <a:endParaRPr b="0" lang="en-GB" sz="2000" spc="-1" strike="noStrike">
               <a:solidFill>
@@ -341,7 +359,7 @@
             <a:pPr indent="0" algn="r">
               <a:buNone/>
             </a:pPr>
-            <a:fld id="{BD6DFF69-7685-4ECE-94CA-863356588897}" type="slidenum">
+            <a:fld id="{48EF70EE-FB3D-47BC-AF45-2984F34E7FE5}" type="slidenum">
               <a:rPr b="0" lang="en-GB" sz="1400" spc="-1" strike="noStrike">
                 <a:solidFill>
                   <a:srgbClr val="000000"/>
@@ -384,7 +402,7 @@
       </p:grpSpPr>
       <p:sp>
         <p:nvSpPr>
-          <p:cNvPr id="241" name="PlaceHolder 1"/>
+          <p:cNvPr id="252" name="PlaceHolder 1"/>
           <p:cNvSpPr>
             <a:spLocks noGrp="1"/>
           </p:cNvSpPr>
@@ -407,7 +425,7 @@
       </p:sp>
       <p:sp>
         <p:nvSpPr>
-          <p:cNvPr id="242" name="PlaceHolder 2"/>
+          <p:cNvPr id="253" name="PlaceHolder 2"/>
           <p:cNvSpPr>
             <a:spLocks noGrp="1"/>
           </p:cNvSpPr>
@@ -518,7 +536,7 @@
       </p:grpSpPr>
       <p:sp>
         <p:nvSpPr>
-          <p:cNvPr id="243" name="PlaceHolder 1"/>
+          <p:cNvPr id="254" name="PlaceHolder 1"/>
           <p:cNvSpPr>
             <a:spLocks noGrp="1"/>
           </p:cNvSpPr>
@@ -541,7 +559,7 @@
       </p:sp>
       <p:sp>
         <p:nvSpPr>
-          <p:cNvPr id="244" name="PlaceHolder 2"/>
+          <p:cNvPr id="255" name="PlaceHolder 2"/>
           <p:cNvSpPr>
             <a:spLocks noGrp="1"/>
           </p:cNvSpPr>
@@ -652,7 +670,7 @@
       </p:grpSpPr>
       <p:sp>
         <p:nvSpPr>
-          <p:cNvPr id="245" name="PlaceHolder 1"/>
+          <p:cNvPr id="256" name="PlaceHolder 1"/>
           <p:cNvSpPr>
             <a:spLocks noGrp="1"/>
           </p:cNvSpPr>
@@ -675,7 +693,7 @@
       </p:sp>
       <p:sp>
         <p:nvSpPr>
-          <p:cNvPr id="246" name="PlaceHolder 2"/>
+          <p:cNvPr id="257" name="PlaceHolder 2"/>
           <p:cNvSpPr>
             <a:spLocks noGrp="1"/>
           </p:cNvSpPr>
@@ -786,7 +804,7 @@
       </p:grpSpPr>
       <p:sp>
         <p:nvSpPr>
-          <p:cNvPr id="247" name="PlaceHolder 1"/>
+          <p:cNvPr id="258" name="PlaceHolder 1"/>
           <p:cNvSpPr>
             <a:spLocks noGrp="1"/>
           </p:cNvSpPr>
@@ -809,7 +827,7 @@
       </p:sp>
       <p:sp>
         <p:nvSpPr>
-          <p:cNvPr id="248" name="PlaceHolder 2"/>
+          <p:cNvPr id="259" name="PlaceHolder 2"/>
           <p:cNvSpPr>
             <a:spLocks noGrp="1"/>
           </p:cNvSpPr>
@@ -952,7 +970,7 @@
         <p:txBody>
           <a:bodyPr/>
           <a:p>
-            <a:fld id="{AA1B23B8-496D-4153-B52D-D0BD04D40AC4}" type="slidenum">
+            <a:fld id="{456367F0-D89E-4838-9C6D-E43ED95324ED}" type="slidenum">
               <a:t>&lt;#&gt;</a:t>
             </a:fld>
           </a:p>
@@ -1115,7 +1133,7 @@
         <p:txBody>
           <a:bodyPr/>
           <a:p>
-            <a:fld id="{4DF41B70-C354-4E18-B257-C0FD1541BB58}" type="slidenum">
+            <a:fld id="{B768B106-50D5-4D41-9DFD-D1E1F11E94B6}" type="slidenum">
               <a:t>&lt;#&gt;</a:t>
             </a:fld>
           </a:p>
@@ -1354,7 +1372,7 @@
               </a:lnSpc>
               <a:buNone/>
             </a:pPr>
-            <a:fld id="{20B7BCFF-11BA-40D2-AD04-241AADFAAE74}" type="slidenum">
+            <a:fld id="{EC4F9C34-B4CF-4ED2-8295-B77E29DC27BD}" type="slidenum">
               <a:rPr b="0" lang="en-GB" sz="1200" spc="-1" strike="noStrike">
                 <a:solidFill>
                   <a:schemeClr val="dk1">
@@ -1413,7 +1431,34 @@
                 </a:solidFill>
                 <a:latin typeface="Aptos"/>
               </a:rPr>
-              <a:t>Click to edit the title text format</a:t>
+              <a:t>Click to </a:t>
+            </a:r>
+            <a:r>
+              <a:rPr b="0" lang="en-GB" sz="1800" spc="-1" strike="noStrike">
+                <a:solidFill>
+                  <a:schemeClr val="dk1"/>
+                </a:solidFill>
+                <a:latin typeface="Aptos"/>
+              </a:rPr>
+              <a:t>edit the </a:t>
+            </a:r>
+            <a:r>
+              <a:rPr b="0" lang="en-GB" sz="1800" spc="-1" strike="noStrike">
+                <a:solidFill>
+                  <a:schemeClr val="dk1"/>
+                </a:solidFill>
+                <a:latin typeface="Aptos"/>
+              </a:rPr>
+              <a:t>title text </a:t>
+            </a:r>
+            <a:r>
+              <a:rPr b="0" lang="en-GB" sz="1800" spc="-1" strike="noStrike">
+                <a:solidFill>
+                  <a:schemeClr val="dk1"/>
+                </a:solidFill>
+                <a:latin typeface="Aptos"/>
+              </a:rPr>
+              <a:t>format</a:t>
             </a:r>
             <a:endParaRPr b="0" lang="en-GB" sz="1800" spc="-1" strike="noStrike">
               <a:solidFill>
@@ -3539,76 +3584,30 @@
           <a:chExt cx="0" cy="0"/>
         </a:xfrm>
       </p:grpSpPr>
-      <p:sp>
-        <p:nvSpPr>
-          <p:cNvPr id="40" name=""/>
-          <p:cNvSpPr/>
-          <p:nvPr/>
-        </p:nvSpPr>
-        <p:spPr>
-          <a:xfrm rot="19800000">
-            <a:off x="844200" y="1505520"/>
-            <a:ext cx="2095200" cy="540000"/>
-          </a:xfrm>
-          <a:prstGeom prst="can">
-            <a:avLst>
-              <a:gd name="adj" fmla="val 50000"/>
-            </a:avLst>
-          </a:prstGeom>
-          <a:solidFill>
-            <a:srgbClr val="c8902e"/>
-          </a:solidFill>
-          <a:ln w="38160">
-            <a:solidFill>
-              <a:srgbClr val="1b2a4a"/>
-            </a:solidFill>
-            <a:round/>
-          </a:ln>
-        </p:spPr>
-        <p:style>
-          <a:lnRef idx="0"/>
-          <a:fillRef idx="0"/>
-          <a:effectRef idx="0"/>
-          <a:fontRef idx="minor"/>
-        </p:style>
-        <p:txBody>
-          <a:bodyPr lIns="108720" rIns="108720" tIns="63720" bIns="63720" anchor="ctr">
-            <a:noAutofit/>
-          </a:bodyPr>
-          <a:p>
-            <a:endParaRPr b="0" lang="en-GB" sz="1800" spc="-1" strike="noStrike">
-              <a:solidFill>
-                <a:srgbClr val="ffffff"/>
-              </a:solidFill>
-              <a:latin typeface="Arial"/>
-            </a:endParaRPr>
-          </a:p>
-        </p:txBody>
-      </p:sp>
       <p:grpSp>
         <p:nvGrpSpPr>
-          <p:cNvPr id="41" name="title"/>
+          <p:cNvPr id="40" name="title"/>
           <p:cNvGrpSpPr/>
           <p:nvPr/>
         </p:nvGrpSpPr>
         <p:grpSpPr>
           <a:xfrm>
-            <a:off x="882360" y="533520"/>
-            <a:ext cx="5833440" cy="640440"/>
-            <a:chOff x="882360" y="533520"/>
-            <a:chExt cx="5833440" cy="640440"/>
+            <a:off x="883080" y="533520"/>
+            <a:ext cx="5832000" cy="640440"/>
+            <a:chOff x="883080" y="533520"/>
+            <a:chExt cx="5832000" cy="640440"/>
           </a:xfrm>
         </p:grpSpPr>
         <p:sp>
           <p:nvSpPr>
-            <p:cNvPr id="42" name="TextBox 7"/>
+            <p:cNvPr id="41" name="TextBox 7"/>
             <p:cNvSpPr/>
             <p:nvPr/>
           </p:nvSpPr>
           <p:spPr>
             <a:xfrm>
-              <a:off x="882360" y="533520"/>
-              <a:ext cx="5833440" cy="640440"/>
+              <a:off x="883080" y="533520"/>
+              <a:ext cx="5832000" cy="640440"/>
             </a:xfrm>
             <a:prstGeom prst="rect">
               <a:avLst/>
@@ -3642,7 +3641,17 @@
                   <a:latin typeface="Aptos"/>
                   <a:ea typeface="Microsoft YaHei"/>
                 </a:rPr>
-                <a:t>Capsule of knowledge</a:t>
+                <a:t>Capsule of </a:t>
+              </a:r>
+              <a:r>
+                <a:rPr b="1" lang="en-GB" sz="4200" spc="-1" strike="noStrike">
+                  <a:solidFill>
+                    <a:srgbClr val="1b2a4a"/>
+                  </a:solidFill>
+                  <a:latin typeface="Aptos"/>
+                  <a:ea typeface="Microsoft YaHei"/>
+                </a:rPr>
+                <a:t>knowledge</a:t>
               </a:r>
               <a:endParaRPr b="0" lang="en-GB" sz="4200" spc="-1" strike="noStrike">
                 <a:solidFill>
@@ -3656,14 +3665,14 @@
       </p:grpSp>
       <p:sp>
         <p:nvSpPr>
-          <p:cNvPr id="43" name="Freeform 12"/>
+          <p:cNvPr id="42" name="Freeform 12"/>
           <p:cNvSpPr/>
           <p:nvPr/>
         </p:nvSpPr>
         <p:spPr>
-          <a:xfrm>
-            <a:off x="1733400" y="2495520"/>
-            <a:ext cx="2095200" cy="2190240"/>
+          <a:xfrm rot="21300000">
+            <a:off x="2140920" y="2532600"/>
+            <a:ext cx="1190880" cy="1244880"/>
           </a:xfrm>
           <a:prstGeom prst="can">
             <a:avLst>
@@ -3699,14 +3708,14 @@
       </p:sp>
       <p:sp>
         <p:nvSpPr>
-          <p:cNvPr id="44" name="Freeform 13"/>
+          <p:cNvPr id="43" name="Freeform 13"/>
           <p:cNvSpPr/>
           <p:nvPr/>
         </p:nvSpPr>
         <p:spPr>
-          <a:xfrm>
-            <a:off x="1656000" y="2412000"/>
-            <a:ext cx="2095200" cy="2190240"/>
+          <a:xfrm rot="21300000">
+            <a:off x="2093040" y="2489040"/>
+            <a:ext cx="1190880" cy="1244880"/>
           </a:xfrm>
           <a:prstGeom prst="can">
             <a:avLst>
@@ -3745,28 +3754,28 @@
       </p:sp>
       <p:grpSp>
         <p:nvGrpSpPr>
-          <p:cNvPr id="45" name="Group 18"/>
+          <p:cNvPr id="44" name="Group 18"/>
           <p:cNvGrpSpPr/>
           <p:nvPr/>
         </p:nvGrpSpPr>
         <p:grpSpPr>
           <a:xfrm>
-            <a:off x="1900080" y="1601640"/>
-            <a:ext cx="1738080" cy="1210680"/>
-            <a:chOff x="1900080" y="1601640"/>
-            <a:chExt cx="1738080" cy="1210680"/>
+            <a:off x="2081520" y="1980000"/>
+            <a:ext cx="987840" cy="687960"/>
+            <a:chOff x="2081520" y="1980000"/>
+            <a:chExt cx="987840" cy="687960"/>
           </a:xfrm>
         </p:grpSpPr>
         <p:sp>
           <p:nvSpPr>
-            <p:cNvPr id="46" name="Rectangle 15"/>
+            <p:cNvPr id="45" name="Rectangle 15"/>
             <p:cNvSpPr/>
             <p:nvPr/>
           </p:nvSpPr>
           <p:spPr>
-            <a:xfrm rot="21000000">
-              <a:off x="1980720" y="1771560"/>
-              <a:ext cx="666360" cy="990360"/>
+            <a:xfrm rot="20998800">
+              <a:off x="2127240" y="2076480"/>
+              <a:ext cx="378720" cy="562680"/>
             </a:xfrm>
             <a:prstGeom prst="rect">
               <a:avLst/>
@@ -3803,14 +3812,14 @@
         </p:sp>
         <p:sp>
           <p:nvSpPr>
-            <p:cNvPr id="47" name="Rectangle 16"/>
+            <p:cNvPr id="46" name="Rectangle 16"/>
             <p:cNvSpPr/>
             <p:nvPr/>
           </p:nvSpPr>
           <p:spPr>
-            <a:xfrm rot="420000">
-              <a:off x="2495520" y="1638000"/>
-              <a:ext cx="666360" cy="1104480"/>
+            <a:xfrm rot="419400">
+              <a:off x="2419920" y="2000520"/>
+              <a:ext cx="378720" cy="627840"/>
             </a:xfrm>
             <a:prstGeom prst="rect">
               <a:avLst/>
@@ -3847,14 +3856,14 @@
         </p:sp>
         <p:sp>
           <p:nvSpPr>
-            <p:cNvPr id="48" name="Rectangle 17"/>
+            <p:cNvPr id="47" name="Rectangle 17"/>
             <p:cNvSpPr/>
             <p:nvPr/>
           </p:nvSpPr>
           <p:spPr>
-            <a:xfrm rot="960000">
-              <a:off x="3028680" y="1962000"/>
-              <a:ext cx="514080" cy="761760"/>
+            <a:xfrm rot="961200">
+              <a:off x="2723040" y="2184840"/>
+              <a:ext cx="292320" cy="432720"/>
             </a:xfrm>
             <a:prstGeom prst="roundRect">
               <a:avLst>
@@ -3894,36 +3903,36 @@
       </p:grpSp>
       <p:grpSp>
         <p:nvGrpSpPr>
-          <p:cNvPr id="49" name="Group 23"/>
+          <p:cNvPr id="48" name="Group 23"/>
           <p:cNvGrpSpPr/>
           <p:nvPr/>
         </p:nvGrpSpPr>
         <p:grpSpPr>
           <a:xfrm>
-            <a:off x="2133720" y="1866960"/>
-            <a:ext cx="875880" cy="304560"/>
-            <a:chOff x="2133720" y="1866960"/>
-            <a:chExt cx="875880" cy="304560"/>
+            <a:off x="2129400" y="2062440"/>
+            <a:ext cx="607320" cy="248400"/>
+            <a:chOff x="2129400" y="2062440"/>
+            <a:chExt cx="607320" cy="248400"/>
           </a:xfrm>
         </p:grpSpPr>
         <p:sp>
           <p:nvSpPr>
-            <p:cNvPr id="50" name="Line 19"/>
+            <p:cNvPr id="49" name="Line 19"/>
             <p:cNvSpPr/>
             <p:nvPr/>
           </p:nvSpPr>
           <p:spPr>
-            <a:xfrm>
-              <a:off x="2133720" y="1962000"/>
-              <a:ext cx="361440" cy="56880"/>
+            <a:xfrm rot="21297600">
+              <a:off x="2130480" y="2163600"/>
+              <a:ext cx="237600" cy="38160"/>
             </a:xfrm>
             <a:custGeom>
               <a:avLst/>
               <a:gdLst>
-                <a:gd name="textAreaLeft" fmla="*/ 0 w 361440"/>
-                <a:gd name="textAreaRight" fmla="*/ 361800 w 361440"/>
-                <a:gd name="textAreaTop" fmla="*/ 0 h 56880"/>
-                <a:gd name="textAreaBottom" fmla="*/ 57240 h 56880"/>
+                <a:gd name="textAreaLeft" fmla="*/ 0 w 237600"/>
+                <a:gd name="textAreaRight" fmla="*/ 237960 w 237600"/>
+                <a:gd name="textAreaTop" fmla="*/ 0 h 38160"/>
+                <a:gd name="textAreaBottom" fmla="*/ 38520 h 38160"/>
               </a:gdLst>
               <a:ahLst/>
               <a:rect l="textAreaLeft" t="textAreaTop" r="textAreaRight" b="textAreaBottom"/>
@@ -3953,7 +3962,7 @@
             <a:fontRef idx="minor"/>
           </p:style>
           <p:txBody>
-            <a:bodyPr lIns="90000" rIns="90000" tIns="12240" bIns="12240" anchor="t">
+            <a:bodyPr lIns="90000" rIns="90000" tIns="-6480" bIns="-6480" anchor="t">
               <a:noAutofit/>
             </a:bodyPr>
             <a:p>
@@ -3968,22 +3977,22 @@
         </p:sp>
         <p:sp>
           <p:nvSpPr>
-            <p:cNvPr id="51" name="Line 20"/>
+            <p:cNvPr id="50" name="Line 20"/>
             <p:cNvSpPr/>
             <p:nvPr/>
           </p:nvSpPr>
           <p:spPr>
-            <a:xfrm>
-              <a:off x="2152800" y="2114640"/>
-              <a:ext cx="361440" cy="56880"/>
+            <a:xfrm rot="21297000">
+              <a:off x="2151720" y="2262600"/>
+              <a:ext cx="237240" cy="37440"/>
             </a:xfrm>
             <a:custGeom>
               <a:avLst/>
               <a:gdLst>
-                <a:gd name="textAreaLeft" fmla="*/ 0 w 361440"/>
-                <a:gd name="textAreaRight" fmla="*/ 361800 w 361440"/>
-                <a:gd name="textAreaTop" fmla="*/ 0 h 56880"/>
-                <a:gd name="textAreaBottom" fmla="*/ 57240 h 56880"/>
+                <a:gd name="textAreaLeft" fmla="*/ 0 w 237240"/>
+                <a:gd name="textAreaRight" fmla="*/ 237600 w 237240"/>
+                <a:gd name="textAreaTop" fmla="*/ 0 h 37440"/>
+                <a:gd name="textAreaBottom" fmla="*/ 37800 h 37440"/>
               </a:gdLst>
               <a:ahLst/>
               <a:rect l="textAreaLeft" t="textAreaTop" r="textAreaRight" b="textAreaBottom"/>
@@ -4013,7 +4022,7 @@
             <a:fontRef idx="minor"/>
           </p:style>
           <p:txBody>
-            <a:bodyPr lIns="90000" rIns="90000" tIns="12240" bIns="12240" anchor="t">
+            <a:bodyPr lIns="90000" rIns="90000" tIns="-7200" bIns="-7200" anchor="t">
               <a:noAutofit/>
             </a:bodyPr>
             <a:p>
@@ -4028,22 +4037,22 @@
         </p:sp>
         <p:sp>
           <p:nvSpPr>
-            <p:cNvPr id="52" name="Line 21"/>
+            <p:cNvPr id="51" name="Line 21"/>
             <p:cNvSpPr/>
             <p:nvPr/>
           </p:nvSpPr>
           <p:spPr>
-            <a:xfrm>
-              <a:off x="2666880" y="1866960"/>
-              <a:ext cx="342720" cy="37800"/>
+            <a:xfrm rot="21303600">
+              <a:off x="2509560" y="2071800"/>
+              <a:ext cx="225720" cy="24840"/>
             </a:xfrm>
             <a:custGeom>
               <a:avLst/>
               <a:gdLst>
-                <a:gd name="textAreaLeft" fmla="*/ 0 w 342720"/>
-                <a:gd name="textAreaRight" fmla="*/ 343080 w 342720"/>
-                <a:gd name="textAreaTop" fmla="*/ 0 h 37800"/>
-                <a:gd name="textAreaBottom" fmla="*/ 38160 h 37800"/>
+                <a:gd name="textAreaLeft" fmla="*/ 0 w 225720"/>
+                <a:gd name="textAreaRight" fmla="*/ 226080 w 225720"/>
+                <a:gd name="textAreaTop" fmla="*/ 0 h 24840"/>
+                <a:gd name="textAreaBottom" fmla="*/ 25200 h 24840"/>
               </a:gdLst>
               <a:ahLst/>
               <a:rect l="textAreaLeft" t="textAreaTop" r="textAreaRight" b="textAreaBottom"/>
@@ -4073,7 +4082,7 @@
             <a:fontRef idx="minor"/>
           </p:style>
           <p:txBody>
-            <a:bodyPr lIns="90000" rIns="90000" tIns="-6840" bIns="-6840" anchor="t">
+            <a:bodyPr lIns="90000" rIns="90000" tIns="-19800" bIns="-19800" anchor="t">
               <a:noAutofit/>
             </a:bodyPr>
             <a:p>
@@ -4088,22 +4097,22 @@
         </p:sp>
         <p:sp>
           <p:nvSpPr>
-            <p:cNvPr id="53" name="Line 22"/>
+            <p:cNvPr id="52" name="Line 22"/>
             <p:cNvSpPr/>
             <p:nvPr/>
           </p:nvSpPr>
           <p:spPr>
-            <a:xfrm>
-              <a:off x="2647800" y="2019240"/>
-              <a:ext cx="342720" cy="37800"/>
+            <a:xfrm rot="21309600">
+              <a:off x="2505960" y="2172600"/>
+              <a:ext cx="225360" cy="24840"/>
             </a:xfrm>
             <a:custGeom>
               <a:avLst/>
               <a:gdLst>
-                <a:gd name="textAreaLeft" fmla="*/ 0 w 342720"/>
-                <a:gd name="textAreaRight" fmla="*/ 343080 w 342720"/>
-                <a:gd name="textAreaTop" fmla="*/ 0 h 37800"/>
-                <a:gd name="textAreaBottom" fmla="*/ 38160 h 37800"/>
+                <a:gd name="textAreaLeft" fmla="*/ 0 w 225360"/>
+                <a:gd name="textAreaRight" fmla="*/ 225720 w 225360"/>
+                <a:gd name="textAreaTop" fmla="*/ 0 h 24840"/>
+                <a:gd name="textAreaBottom" fmla="*/ 25200 h 24840"/>
               </a:gdLst>
               <a:ahLst/>
               <a:rect l="textAreaLeft" t="textAreaTop" r="textAreaRight" b="textAreaBottom"/>
@@ -4133,7 +4142,7 @@
             <a:fontRef idx="minor"/>
           </p:style>
           <p:txBody>
-            <a:bodyPr lIns="90000" rIns="90000" tIns="-6840" bIns="-6840" anchor="t">
+            <a:bodyPr lIns="90000" rIns="90000" tIns="-19800" bIns="-19800" anchor="t">
               <a:noAutofit/>
             </a:bodyPr>
             <a:p>
@@ -4149,22 +4158,22 @@
       </p:grpSp>
       <p:sp>
         <p:nvSpPr>
-          <p:cNvPr id="54" name="Freeform 24"/>
+          <p:cNvPr id="53" name="Freeform 24"/>
           <p:cNvSpPr/>
           <p:nvPr/>
         </p:nvSpPr>
         <p:spPr>
-          <a:xfrm>
-            <a:off x="2639520" y="2152800"/>
-            <a:ext cx="789120" cy="380520"/>
+          <a:xfrm rot="21300000">
+            <a:off x="2593440" y="2327760"/>
+            <a:ext cx="448560" cy="216360"/>
           </a:xfrm>
           <a:custGeom>
             <a:avLst/>
             <a:gdLst>
-              <a:gd name="textAreaLeft" fmla="*/ 0 w 789120"/>
-              <a:gd name="textAreaRight" fmla="*/ 789480 w 789120"/>
-              <a:gd name="textAreaTop" fmla="*/ 0 h 380520"/>
-              <a:gd name="textAreaBottom" fmla="*/ 380880 h 380520"/>
+              <a:gd name="textAreaLeft" fmla="*/ 0 w 448560"/>
+              <a:gd name="textAreaRight" fmla="*/ 448920 w 448560"/>
+              <a:gd name="textAreaTop" fmla="*/ 0 h 216360"/>
+              <a:gd name="textAreaBottom" fmla="*/ 216720 h 216360"/>
             </a:gdLst>
             <a:ahLst/>
             <a:rect l="textAreaLeft" t="textAreaTop" r="textAreaRight" b="textAreaBottom"/>
@@ -4247,7 +4256,7 @@
       </p:sp>
       <p:grpSp>
         <p:nvGrpSpPr>
-          <p:cNvPr id="55" name="inside-capsule"/>
+          <p:cNvPr id="54" name="inside-capsule"/>
           <p:cNvGrpSpPr/>
           <p:nvPr/>
         </p:nvGrpSpPr>
@@ -4261,7 +4270,7 @@
         </p:grpSpPr>
         <p:sp>
           <p:nvSpPr>
-            <p:cNvPr id="56" name="TextBox 27"/>
+            <p:cNvPr id="55" name="TextBox 27"/>
             <p:cNvSpPr/>
             <p:nvPr/>
           </p:nvSpPr>
@@ -4315,7 +4324,7 @@
         </p:sp>
         <p:grpSp>
           <p:nvGrpSpPr>
-            <p:cNvPr id="57" name="Group 32"/>
+            <p:cNvPr id="56" name="Group 32"/>
             <p:cNvGrpSpPr/>
             <p:nvPr/>
           </p:nvGrpSpPr>
@@ -4329,7 +4338,7 @@
           </p:grpSpPr>
           <p:sp>
             <p:nvSpPr>
-              <p:cNvPr id="58" name="Rectangle 28"/>
+              <p:cNvPr id="57" name="Rectangle 28"/>
               <p:cNvSpPr/>
               <p:nvPr/>
             </p:nvSpPr>
@@ -4372,7 +4381,7 @@
           </p:sp>
           <p:sp>
             <p:nvSpPr>
-              <p:cNvPr id="59" name="Rectangle 29"/>
+              <p:cNvPr id="58" name="Rectangle 29"/>
               <p:cNvSpPr/>
               <p:nvPr/>
             </p:nvSpPr>
@@ -4415,7 +4424,7 @@
           </p:sp>
           <p:sp>
             <p:nvSpPr>
-              <p:cNvPr id="60" name="Rectangle 30"/>
+              <p:cNvPr id="59" name="Rectangle 30"/>
               <p:cNvSpPr/>
               <p:nvPr/>
             </p:nvSpPr>
@@ -4458,7 +4467,7 @@
           </p:sp>
           <p:sp>
             <p:nvSpPr>
-              <p:cNvPr id="61" name="Rectangle 31"/>
+              <p:cNvPr id="60" name="Rectangle 31"/>
               <p:cNvSpPr/>
               <p:nvPr/>
             </p:nvSpPr>
@@ -4502,7 +4511,7 @@
         </p:grpSp>
         <p:grpSp>
           <p:nvGrpSpPr>
-            <p:cNvPr id="62" name="Group 37"/>
+            <p:cNvPr id="61" name="Group 37"/>
             <p:cNvGrpSpPr/>
             <p:nvPr/>
           </p:nvGrpSpPr>
@@ -4516,7 +4525,7 @@
           </p:grpSpPr>
           <p:sp>
             <p:nvSpPr>
-              <p:cNvPr id="63" name="Rectangle 33"/>
+              <p:cNvPr id="62" name="Rectangle 33"/>
               <p:cNvSpPr/>
               <p:nvPr/>
             </p:nvSpPr>
@@ -4562,7 +4571,7 @@
           </p:sp>
           <p:sp>
             <p:nvSpPr>
-              <p:cNvPr id="64" name="Rectangle 34"/>
+              <p:cNvPr id="63" name="Rectangle 34"/>
               <p:cNvSpPr/>
               <p:nvPr/>
             </p:nvSpPr>
@@ -4608,7 +4617,7 @@
           </p:sp>
           <p:sp>
             <p:nvSpPr>
-              <p:cNvPr id="65" name="Rectangle 35"/>
+              <p:cNvPr id="64" name="Rectangle 35"/>
               <p:cNvSpPr/>
               <p:nvPr/>
             </p:nvSpPr>
@@ -4654,7 +4663,7 @@
           </p:sp>
           <p:sp>
             <p:nvSpPr>
-              <p:cNvPr id="66" name="Rectangle 36"/>
+              <p:cNvPr id="65" name="Rectangle 36"/>
               <p:cNvSpPr/>
               <p:nvPr/>
             </p:nvSpPr>
@@ -4701,7 +4710,7 @@
         </p:grpSp>
         <p:grpSp>
           <p:nvGrpSpPr>
-            <p:cNvPr id="67" name="Group 43"/>
+            <p:cNvPr id="66" name="Group 43"/>
             <p:cNvGrpSpPr/>
             <p:nvPr/>
           </p:nvGrpSpPr>
@@ -4715,7 +4724,7 @@
           </p:grpSpPr>
           <p:sp>
             <p:nvSpPr>
-              <p:cNvPr id="68" name="Freeform 38"/>
+              <p:cNvPr id="67" name="Freeform 38"/>
               <p:cNvSpPr/>
               <p:nvPr/>
             </p:nvSpPr>
@@ -4783,7 +4792,7 @@
           </p:sp>
           <p:sp>
             <p:nvSpPr>
-              <p:cNvPr id="69" name="Freeform 39"/>
+              <p:cNvPr id="68" name="Freeform 39"/>
               <p:cNvSpPr/>
               <p:nvPr/>
             </p:nvSpPr>
@@ -4870,7 +4879,7 @@
           </p:sp>
           <p:sp>
             <p:nvSpPr>
-              <p:cNvPr id="70" name="Freeform 40"/>
+              <p:cNvPr id="69" name="Freeform 40"/>
               <p:cNvSpPr/>
               <p:nvPr/>
             </p:nvSpPr>
@@ -4930,7 +4939,7 @@
           </p:sp>
           <p:sp>
             <p:nvSpPr>
-              <p:cNvPr id="71" name="Freeform 41"/>
+              <p:cNvPr id="70" name="Freeform 41"/>
               <p:cNvSpPr/>
               <p:nvPr/>
             </p:nvSpPr>
@@ -4990,7 +4999,7 @@
           </p:sp>
           <p:sp>
             <p:nvSpPr>
-              <p:cNvPr id="72" name="Freeform 42"/>
+              <p:cNvPr id="71" name="Freeform 42"/>
               <p:cNvSpPr/>
               <p:nvPr/>
             </p:nvSpPr>
@@ -5051,7 +5060,7 @@
         </p:grpSp>
         <p:grpSp>
           <p:nvGrpSpPr>
-            <p:cNvPr id="73" name="Group 47"/>
+            <p:cNvPr id="72" name="Group 47"/>
             <p:cNvGrpSpPr/>
             <p:nvPr/>
           </p:nvGrpSpPr>
@@ -5065,7 +5074,7 @@
           </p:grpSpPr>
           <p:sp>
             <p:nvSpPr>
-              <p:cNvPr id="74" name="Freeform 44"/>
+              <p:cNvPr id="73" name="Freeform 44"/>
               <p:cNvSpPr/>
               <p:nvPr/>
             </p:nvSpPr>
@@ -5125,7 +5134,7 @@
           </p:sp>
           <p:sp>
             <p:nvSpPr>
-              <p:cNvPr id="75" name="Freeform 45"/>
+              <p:cNvPr id="74" name="Freeform 45"/>
               <p:cNvSpPr/>
               <p:nvPr/>
             </p:nvSpPr>
@@ -5185,7 +5194,7 @@
           </p:sp>
           <p:sp>
             <p:nvSpPr>
-              <p:cNvPr id="76" name="Freeform 46"/>
+              <p:cNvPr id="75" name="Freeform 46"/>
               <p:cNvSpPr/>
               <p:nvPr/>
             </p:nvSpPr>
@@ -5278,7 +5287,7 @@
         </p:grpSp>
         <p:grpSp>
           <p:nvGrpSpPr>
-            <p:cNvPr id="77" name="Group 51"/>
+            <p:cNvPr id="76" name="Group 51"/>
             <p:cNvGrpSpPr/>
             <p:nvPr/>
           </p:nvGrpSpPr>
@@ -5292,7 +5301,7 @@
           </p:grpSpPr>
           <p:sp>
             <p:nvSpPr>
-              <p:cNvPr id="78" name="Freeform 48"/>
+              <p:cNvPr id="77" name="Freeform 48"/>
               <p:cNvSpPr/>
               <p:nvPr/>
             </p:nvSpPr>
@@ -5355,7 +5364,7 @@
           </p:sp>
           <p:sp>
             <p:nvSpPr>
-              <p:cNvPr id="79" name="Freeform 49"/>
+              <p:cNvPr id="78" name="Freeform 49"/>
               <p:cNvSpPr/>
               <p:nvPr/>
             </p:nvSpPr>
@@ -5415,7 +5424,7 @@
           </p:sp>
           <p:sp>
             <p:nvSpPr>
-              <p:cNvPr id="80" name="Freeform 50"/>
+              <p:cNvPr id="79" name="Freeform 50"/>
               <p:cNvSpPr/>
               <p:nvPr/>
             </p:nvSpPr>
@@ -5505,7 +5514,7 @@
         </p:grpSp>
         <p:sp>
           <p:nvSpPr>
-            <p:cNvPr id="81" name="Freeform 52"/>
+            <p:cNvPr id="80" name="Freeform 52"/>
             <p:cNvSpPr/>
             <p:nvPr/>
           </p:nvSpPr>
@@ -5600,7 +5609,7 @@
         </p:sp>
         <p:sp>
           <p:nvSpPr>
-            <p:cNvPr id="82" name="TextBox 53"/>
+            <p:cNvPr id="81" name="TextBox 53"/>
             <p:cNvSpPr/>
             <p:nvPr/>
           </p:nvSpPr>
@@ -5654,7 +5663,7 @@
         </p:sp>
         <p:sp>
           <p:nvSpPr>
-            <p:cNvPr id="83" name="TextBox 54"/>
+            <p:cNvPr id="82" name="TextBox 54"/>
             <p:cNvSpPr/>
             <p:nvPr/>
           </p:nvSpPr>
@@ -5708,7 +5717,7 @@
         </p:sp>
         <p:sp>
           <p:nvSpPr>
-            <p:cNvPr id="84" name="TextBox 55"/>
+            <p:cNvPr id="83" name="TextBox 55"/>
             <p:cNvSpPr/>
             <p:nvPr/>
           </p:nvSpPr>
@@ -5762,7 +5771,7 @@
         </p:sp>
         <p:sp>
           <p:nvSpPr>
-            <p:cNvPr id="85" name="TextBox 56"/>
+            <p:cNvPr id="84" name="TextBox 56"/>
             <p:cNvSpPr/>
             <p:nvPr/>
           </p:nvSpPr>
@@ -5817,7 +5826,7 @@
       </p:grpSp>
       <p:grpSp>
         <p:nvGrpSpPr>
-          <p:cNvPr id="86" name="capsule-facts"/>
+          <p:cNvPr id="85" name="capsule-facts"/>
           <p:cNvGrpSpPr/>
           <p:nvPr/>
         </p:nvGrpSpPr>
@@ -5831,7 +5840,7 @@
         </p:grpSpPr>
         <p:grpSp>
           <p:nvGrpSpPr>
-            <p:cNvPr id="87" name="Group 62"/>
+            <p:cNvPr id="86" name="Group 62"/>
             <p:cNvGrpSpPr/>
             <p:nvPr/>
           </p:nvGrpSpPr>
@@ -5845,7 +5854,7 @@
           </p:grpSpPr>
           <p:sp>
             <p:nvSpPr>
-              <p:cNvPr id="88" name="TextBox 59"/>
+              <p:cNvPr id="87" name="TextBox 59"/>
               <p:cNvSpPr/>
               <p:nvPr/>
             </p:nvSpPr>
@@ -5899,7 +5908,7 @@
           </p:sp>
           <p:sp>
             <p:nvSpPr>
-              <p:cNvPr id="89" name="TextBox 60"/>
+              <p:cNvPr id="88" name="TextBox 60"/>
               <p:cNvSpPr/>
               <p:nvPr/>
             </p:nvSpPr>
@@ -5953,7 +5962,7 @@
           </p:sp>
           <p:sp>
             <p:nvSpPr>
-              <p:cNvPr id="90" name="TextBox 61"/>
+              <p:cNvPr id="89" name="TextBox 61"/>
               <p:cNvSpPr/>
               <p:nvPr/>
             </p:nvSpPr>
@@ -6008,7 +6017,7 @@
         </p:grpSp>
         <p:sp>
           <p:nvSpPr>
-            <p:cNvPr id="91" name="TextBox 63"/>
+            <p:cNvPr id="90" name="TextBox 63"/>
             <p:cNvSpPr/>
             <p:nvPr/>
           </p:nvSpPr>
@@ -6063,7 +6072,7 @@
       </p:grpSp>
       <p:grpSp>
         <p:nvGrpSpPr>
-          <p:cNvPr id="92" name="steps"/>
+          <p:cNvPr id="91" name="steps"/>
           <p:cNvGrpSpPr/>
           <p:nvPr/>
         </p:nvGrpSpPr>
@@ -6077,7 +6086,7 @@
         </p:grpSpPr>
         <p:sp>
           <p:nvSpPr>
-            <p:cNvPr id="93" name="TextBox 65"/>
+            <p:cNvPr id="92" name="TextBox 65"/>
             <p:cNvSpPr/>
             <p:nvPr/>
           </p:nvSpPr>
@@ -6131,7 +6140,7 @@
         </p:sp>
         <p:grpSp>
           <p:nvGrpSpPr>
-            <p:cNvPr id="94" name="Group 71"/>
+            <p:cNvPr id="93" name="Group 71"/>
             <p:cNvGrpSpPr/>
             <p:nvPr/>
           </p:nvGrpSpPr>
@@ -6145,7 +6154,7 @@
           </p:grpSpPr>
           <p:sp>
             <p:nvSpPr>
-              <p:cNvPr id="95" name="Rectangle 66"/>
+              <p:cNvPr id="94" name="Rectangle 66"/>
               <p:cNvSpPr/>
               <p:nvPr/>
             </p:nvSpPr>
@@ -6188,7 +6197,7 @@
           </p:sp>
           <p:sp>
             <p:nvSpPr>
-              <p:cNvPr id="96" name="Rectangle 67"/>
+              <p:cNvPr id="95" name="Rectangle 67"/>
               <p:cNvSpPr/>
               <p:nvPr/>
             </p:nvSpPr>
@@ -6231,7 +6240,7 @@
           </p:sp>
           <p:sp>
             <p:nvSpPr>
-              <p:cNvPr id="97" name="Rectangle 68"/>
+              <p:cNvPr id="96" name="Rectangle 68"/>
               <p:cNvSpPr/>
               <p:nvPr/>
             </p:nvSpPr>
@@ -6274,7 +6283,7 @@
           </p:sp>
           <p:sp>
             <p:nvSpPr>
-              <p:cNvPr id="98" name="Rectangle 69"/>
+              <p:cNvPr id="97" name="Rectangle 69"/>
               <p:cNvSpPr/>
               <p:nvPr/>
             </p:nvSpPr>
@@ -6317,7 +6326,7 @@
           </p:sp>
           <p:sp>
             <p:nvSpPr>
-              <p:cNvPr id="99" name="Rectangle 70"/>
+              <p:cNvPr id="98" name="Rectangle 70"/>
               <p:cNvSpPr/>
               <p:nvPr/>
             </p:nvSpPr>
@@ -6361,7 +6370,7 @@
         </p:grpSp>
         <p:grpSp>
           <p:nvGrpSpPr>
-            <p:cNvPr id="100" name="Group 76"/>
+            <p:cNvPr id="99" name="Group 76"/>
             <p:cNvGrpSpPr/>
             <p:nvPr/>
           </p:nvGrpSpPr>
@@ -6375,7 +6384,7 @@
           </p:grpSpPr>
           <p:sp>
             <p:nvSpPr>
-              <p:cNvPr id="101" name="Rectangle 72"/>
+              <p:cNvPr id="100" name="Rectangle 72"/>
               <p:cNvSpPr/>
               <p:nvPr/>
             </p:nvSpPr>
@@ -6421,7 +6430,7 @@
           </p:sp>
           <p:sp>
             <p:nvSpPr>
-              <p:cNvPr id="102" name="Rectangle 73"/>
+              <p:cNvPr id="101" name="Rectangle 73"/>
               <p:cNvSpPr/>
               <p:nvPr/>
             </p:nvSpPr>
@@ -6467,7 +6476,7 @@
           </p:sp>
           <p:sp>
             <p:nvSpPr>
-              <p:cNvPr id="103" name="Rectangle 74"/>
+              <p:cNvPr id="102" name="Rectangle 74"/>
               <p:cNvSpPr/>
               <p:nvPr/>
             </p:nvSpPr>
@@ -6513,7 +6522,7 @@
           </p:sp>
           <p:sp>
             <p:nvSpPr>
-              <p:cNvPr id="104" name="Rectangle 75"/>
+              <p:cNvPr id="103" name="Rectangle 75"/>
               <p:cNvSpPr/>
               <p:nvPr/>
             </p:nvSpPr>
@@ -6560,7 +6569,7 @@
         </p:grpSp>
         <p:sp>
           <p:nvSpPr>
-            <p:cNvPr id="105" name="Rectangle 77"/>
+            <p:cNvPr id="104" name="Rectangle 77"/>
             <p:cNvSpPr/>
             <p:nvPr/>
           </p:nvSpPr>
@@ -6606,7 +6615,7 @@
         </p:sp>
         <p:sp>
           <p:nvSpPr>
-            <p:cNvPr id="106" name="Freeform 78"/>
+            <p:cNvPr id="105" name="Freeform 78"/>
             <p:cNvSpPr/>
             <p:nvPr/>
           </p:nvSpPr>
@@ -6650,7 +6659,7 @@
         </p:sp>
         <p:sp>
           <p:nvSpPr>
-            <p:cNvPr id="107" name="Freeform 79"/>
+            <p:cNvPr id="106" name="Freeform 79"/>
             <p:cNvSpPr/>
             <p:nvPr/>
           </p:nvSpPr>
@@ -6694,7 +6703,7 @@
         </p:sp>
         <p:sp>
           <p:nvSpPr>
-            <p:cNvPr id="108" name="Freeform 80"/>
+            <p:cNvPr id="107" name="Freeform 80"/>
             <p:cNvSpPr/>
             <p:nvPr/>
           </p:nvSpPr>
@@ -6738,7 +6747,7 @@
         </p:sp>
         <p:sp>
           <p:nvSpPr>
-            <p:cNvPr id="109" name="Freeform 81"/>
+            <p:cNvPr id="108" name="Freeform 81"/>
             <p:cNvSpPr/>
             <p:nvPr/>
           </p:nvSpPr>
@@ -6782,7 +6791,7 @@
         </p:sp>
         <p:grpSp>
           <p:nvGrpSpPr>
-            <p:cNvPr id="110" name="Group 87"/>
+            <p:cNvPr id="109" name="Group 87"/>
             <p:cNvGrpSpPr/>
             <p:nvPr/>
           </p:nvGrpSpPr>
@@ -6796,7 +6805,7 @@
           </p:grpSpPr>
           <p:sp>
             <p:nvSpPr>
-              <p:cNvPr id="111" name="TextBox 82"/>
+              <p:cNvPr id="110" name="TextBox 82"/>
               <p:cNvSpPr/>
               <p:nvPr/>
             </p:nvSpPr>
@@ -6850,7 +6859,7 @@
           </p:sp>
           <p:sp>
             <p:nvSpPr>
-              <p:cNvPr id="112" name="TextBox 83"/>
+              <p:cNvPr id="111" name="TextBox 83"/>
               <p:cNvSpPr/>
               <p:nvPr/>
             </p:nvSpPr>
@@ -6904,7 +6913,7 @@
           </p:sp>
           <p:sp>
             <p:nvSpPr>
-              <p:cNvPr id="113" name="TextBox 84"/>
+              <p:cNvPr id="112" name="TextBox 84"/>
               <p:cNvSpPr/>
               <p:nvPr/>
             </p:nvSpPr>
@@ -6958,7 +6967,7 @@
           </p:sp>
           <p:sp>
             <p:nvSpPr>
-              <p:cNvPr id="114" name="TextBox 85"/>
+              <p:cNvPr id="113" name="TextBox 85"/>
               <p:cNvSpPr/>
               <p:nvPr/>
             </p:nvSpPr>
@@ -7012,7 +7021,7 @@
           </p:sp>
           <p:sp>
             <p:nvSpPr>
-              <p:cNvPr id="115" name="TextBox 86"/>
+              <p:cNvPr id="114" name="TextBox 86"/>
               <p:cNvSpPr/>
               <p:nvPr/>
             </p:nvSpPr>
@@ -7067,7 +7076,7 @@
         </p:grpSp>
         <p:grpSp>
           <p:nvGrpSpPr>
-            <p:cNvPr id="116" name="Group 93"/>
+            <p:cNvPr id="115" name="Group 93"/>
             <p:cNvGrpSpPr/>
             <p:nvPr/>
           </p:nvGrpSpPr>
@@ -7081,7 +7090,7 @@
           </p:grpSpPr>
           <p:sp>
             <p:nvSpPr>
-              <p:cNvPr id="117" name="TextBox 88"/>
+              <p:cNvPr id="116" name="TextBox 88"/>
               <p:cNvSpPr/>
               <p:nvPr/>
             </p:nvSpPr>
@@ -7135,7 +7144,7 @@
           </p:sp>
           <p:sp>
             <p:nvSpPr>
-              <p:cNvPr id="118" name="TextBox 89"/>
+              <p:cNvPr id="117" name="TextBox 89"/>
               <p:cNvSpPr/>
               <p:nvPr/>
             </p:nvSpPr>
@@ -7189,7 +7198,7 @@
           </p:sp>
           <p:sp>
             <p:nvSpPr>
-              <p:cNvPr id="119" name="TextBox 90"/>
+              <p:cNvPr id="118" name="TextBox 90"/>
               <p:cNvSpPr/>
               <p:nvPr/>
             </p:nvSpPr>
@@ -7243,7 +7252,7 @@
           </p:sp>
           <p:sp>
             <p:nvSpPr>
-              <p:cNvPr id="120" name="TextBox 91"/>
+              <p:cNvPr id="119" name="TextBox 91"/>
               <p:cNvSpPr/>
               <p:nvPr/>
             </p:nvSpPr>
@@ -7297,7 +7306,7 @@
           </p:sp>
           <p:sp>
             <p:nvSpPr>
-              <p:cNvPr id="121" name="TextBox 92"/>
+              <p:cNvPr id="120" name="TextBox 92"/>
               <p:cNvSpPr/>
               <p:nvPr/>
             </p:nvSpPr>
@@ -7351,6 +7360,967 @@
           </p:sp>
         </p:grpSp>
       </p:grpSp>
+      <p:sp>
+        <p:nvSpPr>
+          <p:cNvPr id="121" name="Rectangle 9"/>
+          <p:cNvSpPr/>
+          <p:nvPr/>
+        </p:nvSpPr>
+        <p:spPr>
+          <a:xfrm>
+            <a:off x="762480" y="4252320"/>
+            <a:ext cx="3809520" cy="475920"/>
+          </a:xfrm>
+          <a:prstGeom prst="rect">
+            <a:avLst/>
+          </a:prstGeom>
+          <a:solidFill>
+            <a:schemeClr val="lt2"/>
+          </a:solidFill>
+          <a:ln w="0">
+            <a:noFill/>
+          </a:ln>
+        </p:spPr>
+        <p:style>
+          <a:lnRef idx="0"/>
+          <a:fillRef idx="0"/>
+          <a:effectRef idx="0"/>
+          <a:fontRef idx="minor"/>
+        </p:style>
+        <p:txBody>
+          <a:bodyPr lIns="90000" rIns="90000" tIns="45000" bIns="45000" anchor="t">
+            <a:noAutofit/>
+          </a:bodyPr>
+          <a:p>
+            <a:endParaRPr b="0" lang="en-GB" sz="1800" spc="-1" strike="noStrike">
+              <a:solidFill>
+                <a:schemeClr val="dk1"/>
+              </a:solidFill>
+              <a:latin typeface="Aptos"/>
+              <a:ea typeface="Microsoft YaHei"/>
+            </a:endParaRPr>
+          </a:p>
+        </p:txBody>
+      </p:sp>
+      <p:grpSp>
+        <p:nvGrpSpPr>
+          <p:cNvPr id="122" name="Group 16"/>
+          <p:cNvGrpSpPr/>
+          <p:nvPr/>
+        </p:nvGrpSpPr>
+        <p:grpSpPr>
+          <a:xfrm>
+            <a:off x="914760" y="4395240"/>
+            <a:ext cx="3476520" cy="266400"/>
+            <a:chOff x="914760" y="4395240"/>
+            <a:chExt cx="3476520" cy="266400"/>
+          </a:xfrm>
+        </p:grpSpPr>
+        <p:sp>
+          <p:nvSpPr>
+            <p:cNvPr id="123" name="Ellipse 10"/>
+            <p:cNvSpPr/>
+            <p:nvPr/>
+          </p:nvSpPr>
+          <p:spPr>
+            <a:xfrm>
+              <a:off x="914760" y="4443120"/>
+              <a:ext cx="75960" cy="75960"/>
+            </a:xfrm>
+            <a:prstGeom prst="ellipse">
+              <a:avLst/>
+            </a:prstGeom>
+            <a:solidFill>
+              <a:schemeClr val="accent6"/>
+            </a:solidFill>
+            <a:ln w="0">
+              <a:noFill/>
+            </a:ln>
+          </p:spPr>
+          <p:style>
+            <a:lnRef idx="0"/>
+            <a:fillRef idx="0"/>
+            <a:effectRef idx="0"/>
+            <a:fontRef idx="minor"/>
+          </p:style>
+          <p:txBody>
+            <a:bodyPr lIns="90000" rIns="90000" tIns="8640" bIns="8640" anchor="t">
+              <a:noAutofit/>
+            </a:bodyPr>
+            <a:p>
+              <a:endParaRPr b="0" lang="en-GB" sz="1800" spc="-1" strike="noStrike">
+                <a:solidFill>
+                  <a:schemeClr val="dk1"/>
+                </a:solidFill>
+                <a:latin typeface="Aptos"/>
+                <a:ea typeface="Microsoft YaHei"/>
+              </a:endParaRPr>
+            </a:p>
+          </p:txBody>
+        </p:sp>
+        <p:sp>
+          <p:nvSpPr>
+            <p:cNvPr id="124" name="Ellipse 11"/>
+            <p:cNvSpPr/>
+            <p:nvPr/>
+          </p:nvSpPr>
+          <p:spPr>
+            <a:xfrm>
+              <a:off x="2295720" y="4395240"/>
+              <a:ext cx="56880" cy="56880"/>
+            </a:xfrm>
+            <a:prstGeom prst="ellipse">
+              <a:avLst/>
+            </a:prstGeom>
+            <a:solidFill>
+              <a:schemeClr val="accent6"/>
+            </a:solidFill>
+            <a:ln w="0">
+              <a:noFill/>
+            </a:ln>
+          </p:spPr>
+          <p:style>
+            <a:lnRef idx="0"/>
+            <a:fillRef idx="0"/>
+            <a:effectRef idx="0"/>
+            <a:fontRef idx="minor"/>
+          </p:style>
+          <p:txBody>
+            <a:bodyPr lIns="90000" rIns="90000" tIns="-4680" bIns="-4680" anchor="t">
+              <a:noAutofit/>
+            </a:bodyPr>
+            <a:p>
+              <a:endParaRPr b="0" lang="en-GB" sz="1800" spc="-1" strike="noStrike">
+                <a:solidFill>
+                  <a:schemeClr val="dk1"/>
+                </a:solidFill>
+                <a:latin typeface="Aptos"/>
+                <a:ea typeface="Microsoft YaHei"/>
+              </a:endParaRPr>
+            </a:p>
+          </p:txBody>
+        </p:sp>
+        <p:sp>
+          <p:nvSpPr>
+            <p:cNvPr id="125" name="Ellipse 12"/>
+            <p:cNvSpPr/>
+            <p:nvPr/>
+          </p:nvSpPr>
+          <p:spPr>
+            <a:xfrm>
+              <a:off x="2534040" y="4576320"/>
+              <a:ext cx="75960" cy="75960"/>
+            </a:xfrm>
+            <a:prstGeom prst="ellipse">
+              <a:avLst/>
+            </a:prstGeom>
+            <a:solidFill>
+              <a:schemeClr val="accent6"/>
+            </a:solidFill>
+            <a:ln w="0">
+              <a:noFill/>
+            </a:ln>
+          </p:spPr>
+          <p:style>
+            <a:lnRef idx="0"/>
+            <a:fillRef idx="0"/>
+            <a:effectRef idx="0"/>
+            <a:fontRef idx="minor"/>
+          </p:style>
+          <p:txBody>
+            <a:bodyPr lIns="90000" rIns="90000" tIns="8640" bIns="8640" anchor="t">
+              <a:noAutofit/>
+            </a:bodyPr>
+            <a:p>
+              <a:endParaRPr b="0" lang="en-GB" sz="1800" spc="-1" strike="noStrike">
+                <a:solidFill>
+                  <a:schemeClr val="dk1"/>
+                </a:solidFill>
+                <a:latin typeface="Aptos"/>
+                <a:ea typeface="Microsoft YaHei"/>
+              </a:endParaRPr>
+            </a:p>
+          </p:txBody>
+        </p:sp>
+        <p:sp>
+          <p:nvSpPr>
+            <p:cNvPr id="126" name="Ellipse 13"/>
+            <p:cNvSpPr/>
+            <p:nvPr/>
+          </p:nvSpPr>
+          <p:spPr>
+            <a:xfrm>
+              <a:off x="3115080" y="4471560"/>
+              <a:ext cx="56880" cy="56880"/>
+            </a:xfrm>
+            <a:prstGeom prst="ellipse">
+              <a:avLst/>
+            </a:prstGeom>
+            <a:solidFill>
+              <a:schemeClr val="accent6"/>
+            </a:solidFill>
+            <a:ln w="0">
+              <a:noFill/>
+            </a:ln>
+          </p:spPr>
+          <p:style>
+            <a:lnRef idx="0"/>
+            <a:fillRef idx="0"/>
+            <a:effectRef idx="0"/>
+            <a:fontRef idx="minor"/>
+          </p:style>
+          <p:txBody>
+            <a:bodyPr lIns="90000" rIns="90000" tIns="-4680" bIns="-4680" anchor="t">
+              <a:noAutofit/>
+            </a:bodyPr>
+            <a:p>
+              <a:endParaRPr b="0" lang="en-GB" sz="1800" spc="-1" strike="noStrike">
+                <a:solidFill>
+                  <a:schemeClr val="dk1"/>
+                </a:solidFill>
+                <a:latin typeface="Aptos"/>
+                <a:ea typeface="Microsoft YaHei"/>
+              </a:endParaRPr>
+            </a:p>
+          </p:txBody>
+        </p:sp>
+        <p:sp>
+          <p:nvSpPr>
+            <p:cNvPr id="127" name="Ellipse 14"/>
+            <p:cNvSpPr/>
+            <p:nvPr/>
+          </p:nvSpPr>
+          <p:spPr>
+            <a:xfrm>
+              <a:off x="4057920" y="4404960"/>
+              <a:ext cx="75960" cy="75960"/>
+            </a:xfrm>
+            <a:prstGeom prst="ellipse">
+              <a:avLst/>
+            </a:prstGeom>
+            <a:solidFill>
+              <a:schemeClr val="accent6"/>
+            </a:solidFill>
+            <a:ln w="0">
+              <a:noFill/>
+            </a:ln>
+          </p:spPr>
+          <p:style>
+            <a:lnRef idx="0"/>
+            <a:fillRef idx="0"/>
+            <a:effectRef idx="0"/>
+            <a:fontRef idx="minor"/>
+          </p:style>
+          <p:txBody>
+            <a:bodyPr lIns="90000" rIns="90000" tIns="8640" bIns="8640" anchor="t">
+              <a:noAutofit/>
+            </a:bodyPr>
+            <a:p>
+              <a:endParaRPr b="0" lang="en-GB" sz="1800" spc="-1" strike="noStrike">
+                <a:solidFill>
+                  <a:schemeClr val="dk1"/>
+                </a:solidFill>
+                <a:latin typeface="Aptos"/>
+                <a:ea typeface="Microsoft YaHei"/>
+              </a:endParaRPr>
+            </a:p>
+          </p:txBody>
+        </p:sp>
+        <p:sp>
+          <p:nvSpPr>
+            <p:cNvPr id="128" name="Ellipse 15"/>
+            <p:cNvSpPr/>
+            <p:nvPr/>
+          </p:nvSpPr>
+          <p:spPr>
+            <a:xfrm>
+              <a:off x="4334400" y="4604760"/>
+              <a:ext cx="56880" cy="56880"/>
+            </a:xfrm>
+            <a:prstGeom prst="ellipse">
+              <a:avLst/>
+            </a:prstGeom>
+            <a:solidFill>
+              <a:schemeClr val="accent6"/>
+            </a:solidFill>
+            <a:ln w="0">
+              <a:noFill/>
+            </a:ln>
+          </p:spPr>
+          <p:style>
+            <a:lnRef idx="0"/>
+            <a:fillRef idx="0"/>
+            <a:effectRef idx="0"/>
+            <a:fontRef idx="minor"/>
+          </p:style>
+          <p:txBody>
+            <a:bodyPr lIns="90000" rIns="90000" tIns="-4680" bIns="-4680" anchor="t">
+              <a:noAutofit/>
+            </a:bodyPr>
+            <a:p>
+              <a:endParaRPr b="0" lang="en-GB" sz="1800" spc="-1" strike="noStrike">
+                <a:solidFill>
+                  <a:schemeClr val="dk1"/>
+                </a:solidFill>
+                <a:latin typeface="Aptos"/>
+                <a:ea typeface="Microsoft YaHei"/>
+              </a:endParaRPr>
+            </a:p>
+          </p:txBody>
+        </p:sp>
+      </p:grpSp>
+      <p:sp>
+        <p:nvSpPr>
+          <p:cNvPr id="129" name="Freeform 17"/>
+          <p:cNvSpPr/>
+          <p:nvPr/>
+        </p:nvSpPr>
+        <p:spPr>
+          <a:xfrm>
+            <a:off x="1333800" y="4271400"/>
+            <a:ext cx="761760" cy="399600"/>
+          </a:xfrm>
+          <a:custGeom>
+            <a:avLst/>
+            <a:gdLst>
+              <a:gd name="textAreaLeft" fmla="*/ 0 w 761760"/>
+              <a:gd name="textAreaRight" fmla="*/ 762120 w 761760"/>
+              <a:gd name="textAreaTop" fmla="*/ 0 h 399600"/>
+              <a:gd name="textAreaBottom" fmla="*/ 399960 h 399600"/>
+            </a:gdLst>
+            <a:ahLst/>
+            <a:rect l="textAreaLeft" t="textAreaTop" r="textAreaRight" b="textAreaBottom"/>
+            <a:pathLst>
+              <a:path w="762000" h="400050">
+                <a:moveTo>
+                  <a:pt x="0" y="0"/>
+                </a:moveTo>
+                <a:lnTo>
+                  <a:pt x="57150" y="400050"/>
+                </a:lnTo>
+                <a:lnTo>
+                  <a:pt x="704850" y="400050"/>
+                </a:lnTo>
+                <a:lnTo>
+                  <a:pt x="762000" y="0"/>
+                </a:lnTo>
+                <a:close/>
+              </a:path>
+            </a:pathLst>
+          </a:custGeom>
+          <a:solidFill>
+            <a:schemeClr val="accent1"/>
+          </a:solidFill>
+          <a:ln w="0">
+            <a:noFill/>
+          </a:ln>
+        </p:spPr>
+        <p:style>
+          <a:lnRef idx="0"/>
+          <a:fillRef idx="0"/>
+          <a:effectRef idx="0"/>
+          <a:fontRef idx="minor"/>
+        </p:style>
+        <p:txBody>
+          <a:bodyPr lIns="90000" rIns="90000" tIns="45000" bIns="45000" anchor="t">
+            <a:noAutofit/>
+          </a:bodyPr>
+          <a:p>
+            <a:endParaRPr b="0" lang="en-GB" sz="1800" spc="-1" strike="noStrike">
+              <a:solidFill>
+                <a:schemeClr val="dk1"/>
+              </a:solidFill>
+              <a:latin typeface="Aptos"/>
+              <a:ea typeface="Microsoft YaHei"/>
+            </a:endParaRPr>
+          </a:p>
+        </p:txBody>
+      </p:sp>
+      <p:sp>
+        <p:nvSpPr>
+          <p:cNvPr id="130" name="Line 18"/>
+          <p:cNvSpPr/>
+          <p:nvPr/>
+        </p:nvSpPr>
+        <p:spPr>
+          <a:xfrm>
+            <a:off x="762480" y="4252320"/>
+            <a:ext cx="3809520" cy="9000"/>
+          </a:xfrm>
+          <a:custGeom>
+            <a:avLst/>
+            <a:gdLst>
+              <a:gd name="textAreaLeft" fmla="*/ 0 w 3809520"/>
+              <a:gd name="textAreaRight" fmla="*/ 3809880 w 3809520"/>
+              <a:gd name="textAreaTop" fmla="*/ 0 h 9000"/>
+              <a:gd name="textAreaBottom" fmla="*/ 9360 h 9000"/>
+            </a:gdLst>
+            <a:ahLst/>
+            <a:rect l="textAreaLeft" t="textAreaTop" r="textAreaRight" b="textAreaBottom"/>
+            <a:pathLst>
+              <a:path w="3810000" h="9525">
+                <a:moveTo>
+                  <a:pt x="0" y="0"/>
+                </a:moveTo>
+                <a:lnTo>
+                  <a:pt x="3810000" y="0"/>
+                </a:lnTo>
+              </a:path>
+            </a:pathLst>
+          </a:custGeom>
+          <a:noFill/>
+          <a:ln w="28575">
+            <a:solidFill>
+              <a:srgbClr val="1b2a4a"/>
+            </a:solidFill>
+            <a:round/>
+          </a:ln>
+        </p:spPr>
+        <p:style>
+          <a:lnRef idx="0"/>
+          <a:fillRef idx="0"/>
+          <a:effectRef idx="0"/>
+          <a:fontRef idx="minor"/>
+        </p:style>
+        <p:txBody>
+          <a:bodyPr lIns="90000" rIns="90000" tIns="-35640" bIns="-35640" anchor="t">
+            <a:noAutofit/>
+          </a:bodyPr>
+          <a:p>
+            <a:endParaRPr b="0" lang="en-GB" sz="1800" spc="-1" strike="noStrike">
+              <a:solidFill>
+                <a:schemeClr val="dk1"/>
+              </a:solidFill>
+              <a:latin typeface="Aptos"/>
+              <a:ea typeface="Microsoft YaHei"/>
+            </a:endParaRPr>
+          </a:p>
+        </p:txBody>
+      </p:sp>
+      <p:sp>
+        <p:nvSpPr>
+          <p:cNvPr id="131" name="Ellipse 19"/>
+          <p:cNvSpPr/>
+          <p:nvPr/>
+        </p:nvSpPr>
+        <p:spPr>
+          <a:xfrm>
+            <a:off x="1314720" y="4176360"/>
+            <a:ext cx="799920" cy="190080"/>
+          </a:xfrm>
+          <a:prstGeom prst="ellipse">
+            <a:avLst/>
+          </a:prstGeom>
+          <a:solidFill>
+            <a:schemeClr val="accent1"/>
+          </a:solidFill>
+          <a:ln w="0">
+            <a:noFill/>
+          </a:ln>
+        </p:spPr>
+        <p:style>
+          <a:lnRef idx="0"/>
+          <a:fillRef idx="0"/>
+          <a:effectRef idx="0"/>
+          <a:fontRef idx="minor"/>
+        </p:style>
+        <p:txBody>
+          <a:bodyPr lIns="90000" rIns="90000" tIns="45000" bIns="45000" anchor="t">
+            <a:noAutofit/>
+          </a:bodyPr>
+          <a:p>
+            <a:endParaRPr b="0" lang="en-GB" sz="1800" spc="-1" strike="noStrike">
+              <a:solidFill>
+                <a:schemeClr val="dk1"/>
+              </a:solidFill>
+              <a:latin typeface="Aptos"/>
+              <a:ea typeface="Microsoft YaHei"/>
+            </a:endParaRPr>
+          </a:p>
+        </p:txBody>
+      </p:sp>
+      <p:grpSp>
+        <p:nvGrpSpPr>
+          <p:cNvPr id="132" name="Group 22"/>
+          <p:cNvGrpSpPr/>
+          <p:nvPr/>
+        </p:nvGrpSpPr>
+        <p:grpSpPr>
+          <a:xfrm>
+            <a:off x="991080" y="3318840"/>
+            <a:ext cx="304200" cy="819000"/>
+            <a:chOff x="991080" y="3318840"/>
+            <a:chExt cx="304200" cy="819000"/>
+          </a:xfrm>
+        </p:grpSpPr>
+        <p:sp>
+          <p:nvSpPr>
+            <p:cNvPr id="133" name="Line 1"/>
+            <p:cNvSpPr/>
+            <p:nvPr/>
+          </p:nvSpPr>
+          <p:spPr>
+            <a:xfrm>
+              <a:off x="991080" y="3337920"/>
+              <a:ext cx="190080" cy="799920"/>
+            </a:xfrm>
+            <a:custGeom>
+              <a:avLst/>
+              <a:gdLst>
+                <a:gd name="textAreaLeft" fmla="*/ 0 w 190080"/>
+                <a:gd name="textAreaRight" fmla="*/ 190440 w 190080"/>
+                <a:gd name="textAreaTop" fmla="*/ 0 h 799920"/>
+                <a:gd name="textAreaBottom" fmla="*/ 800280 h 799920"/>
+              </a:gdLst>
+              <a:ahLst/>
+              <a:rect l="textAreaLeft" t="textAreaTop" r="textAreaRight" b="textAreaBottom"/>
+              <a:pathLst>
+                <a:path w="190500" h="800100">
+                  <a:moveTo>
+                    <a:pt x="0" y="800100"/>
+                  </a:moveTo>
+                  <a:lnTo>
+                    <a:pt x="190500" y="0"/>
+                  </a:lnTo>
+                </a:path>
+              </a:pathLst>
+            </a:custGeom>
+            <a:noFill/>
+            <a:ln cap="rnd" w="57150">
+              <a:solidFill>
+                <a:srgbClr val="1b2a4a"/>
+              </a:solidFill>
+              <a:round/>
+            </a:ln>
+          </p:spPr>
+          <p:style>
+            <a:lnRef idx="0"/>
+            <a:fillRef idx="0"/>
+            <a:effectRef idx="0"/>
+            <a:fontRef idx="minor"/>
+          </p:style>
+          <p:txBody>
+            <a:bodyPr lIns="90000" rIns="90000" tIns="45000" bIns="45000" anchor="t">
+              <a:noAutofit/>
+            </a:bodyPr>
+            <a:p>
+              <a:endParaRPr b="0" lang="en-GB" sz="1800" spc="-1" strike="noStrike">
+                <a:solidFill>
+                  <a:schemeClr val="dk1"/>
+                </a:solidFill>
+                <a:latin typeface="Aptos"/>
+                <a:ea typeface="Microsoft YaHei"/>
+              </a:endParaRPr>
+            </a:p>
+          </p:txBody>
+        </p:sp>
+        <p:sp>
+          <p:nvSpPr>
+            <p:cNvPr id="134" name="Line 2"/>
+            <p:cNvSpPr/>
+            <p:nvPr/>
+          </p:nvSpPr>
+          <p:spPr>
+            <a:xfrm>
+              <a:off x="1067040" y="3318840"/>
+              <a:ext cx="228240" cy="47160"/>
+            </a:xfrm>
+            <a:custGeom>
+              <a:avLst/>
+              <a:gdLst>
+                <a:gd name="textAreaLeft" fmla="*/ 0 w 228240"/>
+                <a:gd name="textAreaRight" fmla="*/ 228600 w 228240"/>
+                <a:gd name="textAreaTop" fmla="*/ 0 h 47160"/>
+                <a:gd name="textAreaBottom" fmla="*/ 47520 h 47160"/>
+              </a:gdLst>
+              <a:ahLst/>
+              <a:rect l="textAreaLeft" t="textAreaTop" r="textAreaRight" b="textAreaBottom"/>
+              <a:pathLst>
+                <a:path w="228600" h="47625">
+                  <a:moveTo>
+                    <a:pt x="0" y="0"/>
+                  </a:moveTo>
+                  <a:lnTo>
+                    <a:pt x="228600" y="47625"/>
+                  </a:lnTo>
+                </a:path>
+              </a:pathLst>
+            </a:custGeom>
+            <a:noFill/>
+            <a:ln cap="rnd" w="57150">
+              <a:solidFill>
+                <a:srgbClr val="1b2a4a"/>
+              </a:solidFill>
+              <a:round/>
+            </a:ln>
+          </p:spPr>
+          <p:style>
+            <a:lnRef idx="0"/>
+            <a:fillRef idx="0"/>
+            <a:effectRef idx="0"/>
+            <a:fontRef idx="minor"/>
+          </p:style>
+          <p:txBody>
+            <a:bodyPr lIns="90000" rIns="90000" tIns="2520" bIns="2520" anchor="t">
+              <a:noAutofit/>
+            </a:bodyPr>
+            <a:p>
+              <a:endParaRPr b="0" lang="en-GB" sz="1800" spc="-1" strike="noStrike">
+                <a:solidFill>
+                  <a:schemeClr val="dk1"/>
+                </a:solidFill>
+                <a:latin typeface="Aptos"/>
+                <a:ea typeface="Microsoft YaHei"/>
+              </a:endParaRPr>
+            </a:p>
+          </p:txBody>
+        </p:sp>
+      </p:grpSp>
+      <p:sp>
+        <p:nvSpPr>
+          <p:cNvPr id="135" name="Freeform 23"/>
+          <p:cNvSpPr/>
+          <p:nvPr/>
+        </p:nvSpPr>
+        <p:spPr>
+          <a:xfrm>
+            <a:off x="876600" y="3966840"/>
+            <a:ext cx="228240" cy="304560"/>
+          </a:xfrm>
+          <a:custGeom>
+            <a:avLst/>
+            <a:gdLst>
+              <a:gd name="textAreaLeft" fmla="*/ 0 w 228240"/>
+              <a:gd name="textAreaRight" fmla="*/ 228600 w 228240"/>
+              <a:gd name="textAreaTop" fmla="*/ 0 h 304560"/>
+              <a:gd name="textAreaBottom" fmla="*/ 304920 h 304560"/>
+            </a:gdLst>
+            <a:ahLst/>
+            <a:rect l="textAreaLeft" t="textAreaTop" r="textAreaRight" b="textAreaBottom"/>
+            <a:pathLst>
+              <a:path w="228600" h="304800">
+                <a:moveTo>
+                  <a:pt x="0" y="266700"/>
+                </a:moveTo>
+                <a:lnTo>
+                  <a:pt x="57150" y="0"/>
+                </a:lnTo>
+                <a:lnTo>
+                  <a:pt x="228600" y="38100"/>
+                </a:lnTo>
+                <a:lnTo>
+                  <a:pt x="190500" y="304800"/>
+                </a:lnTo>
+                <a:close/>
+              </a:path>
+            </a:pathLst>
+          </a:custGeom>
+          <a:solidFill>
+            <a:schemeClr val="accent3"/>
+          </a:solidFill>
+          <a:ln w="28575">
+            <a:solidFill>
+              <a:srgbClr val="1b2a4a"/>
+            </a:solidFill>
+            <a:round/>
+          </a:ln>
+        </p:spPr>
+        <p:style>
+          <a:lnRef idx="0"/>
+          <a:fillRef idx="0"/>
+          <a:effectRef idx="0"/>
+          <a:fontRef idx="minor"/>
+        </p:style>
+        <p:txBody>
+          <a:bodyPr lIns="90000" rIns="90000" tIns="45000" bIns="45000" anchor="t">
+            <a:noAutofit/>
+          </a:bodyPr>
+          <a:p>
+            <a:endParaRPr b="0" lang="en-GB" sz="1800" spc="-1" strike="noStrike">
+              <a:solidFill>
+                <a:schemeClr val="dk1"/>
+              </a:solidFill>
+              <a:latin typeface="Aptos"/>
+              <a:ea typeface="Microsoft YaHei"/>
+            </a:endParaRPr>
+          </a:p>
+        </p:txBody>
+      </p:sp>
+      <p:sp>
+        <p:nvSpPr>
+          <p:cNvPr id="136" name="Freeform 1"/>
+          <p:cNvSpPr/>
+          <p:nvPr/>
+        </p:nvSpPr>
+        <p:spPr>
+          <a:xfrm>
+            <a:off x="762480" y="3966840"/>
+            <a:ext cx="514080" cy="285480"/>
+          </a:xfrm>
+          <a:custGeom>
+            <a:avLst/>
+            <a:gdLst>
+              <a:gd name="textAreaLeft" fmla="*/ 0 w 514080"/>
+              <a:gd name="textAreaRight" fmla="*/ 514440 w 514080"/>
+              <a:gd name="textAreaTop" fmla="*/ 0 h 285480"/>
+              <a:gd name="textAreaBottom" fmla="*/ 285840 h 285480"/>
+            </a:gdLst>
+            <a:ahLst/>
+            <a:rect l="textAreaLeft" t="textAreaTop" r="textAreaRight" b="textAreaBottom"/>
+            <a:pathLst>
+              <a:path w="514350" h="285750">
+                <a:moveTo>
+                  <a:pt x="0" y="285750"/>
+                </a:moveTo>
+                <a:cubicBezTo>
+                  <a:pt x="76200" y="38100"/>
+                  <a:pt x="400050" y="0"/>
+                  <a:pt x="514350" y="285750"/>
+                </a:cubicBezTo>
+                <a:close/>
+              </a:path>
+            </a:pathLst>
+          </a:custGeom>
+          <a:solidFill>
+            <a:schemeClr val="accent6"/>
+          </a:solidFill>
+          <a:ln w="28575">
+            <a:solidFill>
+              <a:srgbClr val="1b2a4a"/>
+            </a:solidFill>
+            <a:round/>
+          </a:ln>
+        </p:spPr>
+        <p:style>
+          <a:lnRef idx="0"/>
+          <a:fillRef idx="0"/>
+          <a:effectRef idx="0"/>
+          <a:fontRef idx="minor"/>
+        </p:style>
+        <p:txBody>
+          <a:bodyPr lIns="90000" rIns="90000" tIns="45000" bIns="45000" anchor="t">
+            <a:noAutofit/>
+          </a:bodyPr>
+          <a:p>
+            <a:endParaRPr b="0" lang="en-GB" sz="1800" spc="-1" strike="noStrike">
+              <a:solidFill>
+                <a:schemeClr val="dk1"/>
+              </a:solidFill>
+              <a:latin typeface="Aptos"/>
+              <a:ea typeface="Microsoft YaHei"/>
+            </a:endParaRPr>
+          </a:p>
+        </p:txBody>
+      </p:sp>
+      <p:sp>
+        <p:nvSpPr>
+          <p:cNvPr id="137" name="Freeform 2"/>
+          <p:cNvSpPr/>
+          <p:nvPr/>
+        </p:nvSpPr>
+        <p:spPr>
+          <a:xfrm>
+            <a:off x="1752840" y="3600000"/>
+            <a:ext cx="288360" cy="499680"/>
+          </a:xfrm>
+          <a:custGeom>
+            <a:avLst/>
+            <a:gdLst>
+              <a:gd name="textAreaLeft" fmla="*/ 0 w 288360"/>
+              <a:gd name="textAreaRight" fmla="*/ 288720 w 288360"/>
+              <a:gd name="textAreaTop" fmla="*/ 0 h 499680"/>
+              <a:gd name="textAreaBottom" fmla="*/ 500040 h 499680"/>
+            </a:gdLst>
+            <a:ahLst/>
+            <a:rect l="textAreaLeft" t="textAreaTop" r="textAreaRight" b="textAreaBottom"/>
+            <a:pathLst>
+              <a:path w="190500" h="495300">
+                <a:moveTo>
+                  <a:pt x="19050" y="495300"/>
+                </a:moveTo>
+                <a:cubicBezTo>
+                  <a:pt x="0" y="228600"/>
+                  <a:pt x="57150" y="95250"/>
+                  <a:pt x="190500" y="0"/>
+                </a:cubicBezTo>
+              </a:path>
+            </a:pathLst>
+          </a:custGeom>
+          <a:noFill/>
+          <a:ln cap="rnd" w="28575">
+            <a:solidFill>
+              <a:srgbClr val="1b2a4a"/>
+            </a:solidFill>
+            <a:custDash>
+              <a:ds d="200000" sp="200000"/>
+            </a:custDash>
+            <a:round/>
+          </a:ln>
+        </p:spPr>
+        <p:style>
+          <a:lnRef idx="0"/>
+          <a:fillRef idx="0"/>
+          <a:effectRef idx="0"/>
+          <a:fontRef idx="minor"/>
+        </p:style>
+        <p:txBody>
+          <a:bodyPr lIns="90000" rIns="90000" tIns="45000" bIns="45000" anchor="t">
+            <a:noAutofit/>
+          </a:bodyPr>
+          <a:p>
+            <a:endParaRPr b="0" lang="en-GB" sz="1800" spc="-1" strike="noStrike">
+              <a:solidFill>
+                <a:schemeClr val="dk1"/>
+              </a:solidFill>
+              <a:latin typeface="Aptos"/>
+              <a:ea typeface="Microsoft YaHei"/>
+            </a:endParaRPr>
+          </a:p>
+        </p:txBody>
+      </p:sp>
+      <p:sp>
+        <p:nvSpPr>
+          <p:cNvPr id="138" name="文本框 132"/>
+          <p:cNvSpPr/>
+          <p:nvPr/>
+        </p:nvSpPr>
+        <p:spPr>
+          <a:xfrm>
+            <a:off x="2325600" y="4366800"/>
+            <a:ext cx="2143440" cy="363960"/>
+          </a:xfrm>
+          <a:prstGeom prst="rect">
+            <a:avLst/>
+          </a:prstGeom>
+          <a:noFill/>
+          <a:ln w="0">
+            <a:noFill/>
+          </a:ln>
+        </p:spPr>
+        <p:style>
+          <a:lnRef idx="0"/>
+          <a:fillRef idx="0"/>
+          <a:effectRef idx="0"/>
+          <a:fontRef idx="minor"/>
+        </p:style>
+        <p:txBody>
+          <a:bodyPr lIns="90000" rIns="90000" tIns="45000" bIns="45000" anchor="t">
+            <a:spAutoFit/>
+          </a:bodyPr>
+          <a:p>
+            <a:pPr defTabSz="457200">
+              <a:lnSpc>
+                <a:spcPct val="100000"/>
+              </a:lnSpc>
+            </a:pPr>
+            <a:r>
+              <a:rPr b="0" lang="en-US" sz="1800" spc="-1" strike="noStrike">
+                <a:solidFill>
+                  <a:schemeClr val="dk1"/>
+                </a:solidFill>
+                <a:latin typeface="Aptos"/>
+                <a:ea typeface="Microsoft YaHei"/>
+              </a:rPr>
+              <a:t>Previous Tasks</a:t>
+            </a:r>
+            <a:endParaRPr b="0" lang="en-GB" sz="1800" spc="-1" strike="noStrike">
+              <a:solidFill>
+                <a:srgbClr val="000000"/>
+              </a:solidFill>
+              <a:latin typeface="Arial"/>
+            </a:endParaRPr>
+          </a:p>
+        </p:txBody>
+      </p:sp>
+      <p:sp>
+        <p:nvSpPr>
+          <p:cNvPr id="139" name=""/>
+          <p:cNvSpPr/>
+          <p:nvPr/>
+        </p:nvSpPr>
+        <p:spPr>
+          <a:xfrm rot="18600000">
+            <a:off x="1459080" y="1684080"/>
+            <a:ext cx="1227960" cy="333360"/>
+          </a:xfrm>
+          <a:prstGeom prst="can">
+            <a:avLst>
+              <a:gd name="adj" fmla="val 50000"/>
+            </a:avLst>
+          </a:prstGeom>
+          <a:solidFill>
+            <a:srgbClr val="c8902e"/>
+          </a:solidFill>
+          <a:ln w="38160">
+            <a:solidFill>
+              <a:srgbClr val="1b2a4a"/>
+            </a:solidFill>
+            <a:round/>
+          </a:ln>
+        </p:spPr>
+        <p:style>
+          <a:lnRef idx="0"/>
+          <a:fillRef idx="0"/>
+          <a:effectRef idx="0"/>
+          <a:fontRef idx="minor"/>
+        </p:style>
+        <p:txBody>
+          <a:bodyPr lIns="108720" rIns="108720" tIns="19800" bIns="19800" anchor="ctr">
+            <a:noAutofit/>
+          </a:bodyPr>
+          <a:p>
+            <a:endParaRPr b="0" lang="en-GB" sz="1800" spc="-1" strike="noStrike">
+              <a:solidFill>
+                <a:srgbClr val="ffffff"/>
+              </a:solidFill>
+              <a:latin typeface="Arial"/>
+            </a:endParaRPr>
+          </a:p>
+        </p:txBody>
+      </p:sp>
+      <p:sp>
+        <p:nvSpPr>
+          <p:cNvPr id="140" name=""/>
+          <p:cNvSpPr/>
+          <p:nvPr/>
+        </p:nvSpPr>
+        <p:spPr>
+          <a:xfrm>
+            <a:off x="3600000" y="2340000"/>
+            <a:ext cx="1260000" cy="0"/>
+          </a:xfrm>
+          <a:prstGeom prst="line">
+            <a:avLst/>
+          </a:prstGeom>
+          <a:ln w="76320">
+            <a:solidFill>
+              <a:srgbClr val="1b2a4a"/>
+            </a:solidFill>
+            <a:round/>
+            <a:tailEnd len="med" type="triangle" w="med"/>
+          </a:ln>
+        </p:spPr>
+        <p:style>
+          <a:lnRef idx="0"/>
+          <a:fillRef idx="0"/>
+          <a:effectRef idx="0"/>
+          <a:fontRef idx="minor"/>
+        </p:style>
+        <p:txBody>
+          <a:bodyPr lIns="128160" rIns="128160" tIns="-83160" bIns="-83160" anchor="ctr">
+            <a:noAutofit/>
+          </a:bodyPr>
+          <a:p>
+            <a:pPr algn="ctr"/>
+            <a:endParaRPr b="0" lang="en-GB" sz="1800" spc="-1" strike="noStrike">
+              <a:solidFill>
+                <a:srgbClr val="000000"/>
+              </a:solidFill>
+              <a:latin typeface="Arial"/>
+            </a:endParaRPr>
+          </a:p>
+        </p:txBody>
+      </p:sp>
     </p:spTree>
   </p:cSld>
   <mc:AlternateContent>
@@ -7399,7 +8369,7 @@
                                           </p:stCondLst>
                                         </p:cTn>
                                         <p:tgtEl>
-                                          <p:spTgt spid="92"/>
+                                          <p:spTgt spid="91"/>
                                         </p:tgtEl>
                                         <p:attrNameLst>
                                           <p:attrName>style.visibility</p:attrName>
@@ -7413,7 +8383,7 @@
                                       <p:cBhvr additive="repl">
                                         <p:cTn id="22" dur="500"/>
                                         <p:tgtEl>
-                                          <p:spTgt spid="92"/>
+                                          <p:spTgt spid="91"/>
                                         </p:tgtEl>
                                       </p:cBhvr>
                                     </p:animEffect>
@@ -7477,7 +8447,7 @@
       </p:grpSpPr>
       <p:grpSp>
         <p:nvGrpSpPr>
-          <p:cNvPr id="122" name="title"/>
+          <p:cNvPr id="141" name="title"/>
           <p:cNvGrpSpPr/>
           <p:nvPr/>
         </p:nvGrpSpPr>
@@ -7491,7 +8461,7 @@
         </p:grpSpPr>
         <p:sp>
           <p:nvSpPr>
-            <p:cNvPr id="123" name="TextBox 5"/>
+            <p:cNvPr id="142" name="TextBox 5"/>
             <p:cNvSpPr/>
             <p:nvPr/>
           </p:nvSpPr>
@@ -7559,7 +8529,7 @@
       </p:grpSp>
       <p:grpSp>
         <p:nvGrpSpPr>
-          <p:cNvPr id="124" name="target"/>
+          <p:cNvPr id="143" name="target"/>
           <p:cNvGrpSpPr/>
           <p:nvPr/>
         </p:nvGrpSpPr>
@@ -7573,7 +8543,7 @@
         </p:grpSpPr>
         <p:sp>
           <p:nvSpPr>
-            <p:cNvPr id="125" name="Rectangle 7"/>
+            <p:cNvPr id="144" name="Rectangle 7"/>
             <p:cNvSpPr/>
             <p:nvPr/>
           </p:nvSpPr>
@@ -7616,7 +8586,7 @@
         </p:sp>
         <p:sp>
           <p:nvSpPr>
-            <p:cNvPr id="126" name="Rectangle 8"/>
+            <p:cNvPr id="145" name="Rectangle 8"/>
             <p:cNvSpPr/>
             <p:nvPr/>
           </p:nvSpPr>
@@ -7662,7 +8632,7 @@
         </p:sp>
         <p:grpSp>
           <p:nvGrpSpPr>
-            <p:cNvPr id="127" name="Group 12"/>
+            <p:cNvPr id="146" name="Group 12"/>
             <p:cNvGrpSpPr/>
             <p:nvPr/>
           </p:nvGrpSpPr>
@@ -7676,7 +8646,7 @@
           </p:grpSpPr>
           <p:sp>
             <p:nvSpPr>
-              <p:cNvPr id="128" name="Freeform 9"/>
+              <p:cNvPr id="147" name="Freeform 9"/>
               <p:cNvSpPr/>
               <p:nvPr/>
             </p:nvSpPr>
@@ -7736,7 +8706,7 @@
           </p:sp>
           <p:sp>
             <p:nvSpPr>
-              <p:cNvPr id="129" name="Freeform 10"/>
+              <p:cNvPr id="148" name="Freeform 10"/>
               <p:cNvSpPr/>
               <p:nvPr/>
             </p:nvSpPr>
@@ -7813,7 +8783,7 @@
           </p:sp>
           <p:sp>
             <p:nvSpPr>
-              <p:cNvPr id="130" name="Freeform 11"/>
+              <p:cNvPr id="149" name="Freeform 11"/>
               <p:cNvSpPr/>
               <p:nvPr/>
             </p:nvSpPr>
@@ -7891,7 +8861,7 @@
         </p:grpSp>
         <p:sp>
           <p:nvSpPr>
-            <p:cNvPr id="131" name="TextBox 13"/>
+            <p:cNvPr id="150" name="TextBox 13"/>
             <p:cNvSpPr/>
             <p:nvPr/>
           </p:nvSpPr>
@@ -7945,7 +8915,7 @@
         </p:sp>
         <p:sp>
           <p:nvSpPr>
-            <p:cNvPr id="132" name="TextBox 14"/>
+            <p:cNvPr id="151" name="TextBox 14"/>
             <p:cNvSpPr/>
             <p:nvPr/>
           </p:nvSpPr>
@@ -7999,7 +8969,7 @@
         </p:sp>
         <p:sp>
           <p:nvSpPr>
-            <p:cNvPr id="133" name="TextBox 15"/>
+            <p:cNvPr id="152" name="TextBox 15"/>
             <p:cNvSpPr/>
             <p:nvPr/>
           </p:nvSpPr>
@@ -8053,7 +9023,7 @@
         </p:sp>
         <p:sp>
           <p:nvSpPr>
-            <p:cNvPr id="134" name="TextBox 16"/>
+            <p:cNvPr id="153" name="TextBox 16"/>
             <p:cNvSpPr/>
             <p:nvPr/>
           </p:nvSpPr>
@@ -8107,7 +9077,7 @@
         </p:sp>
         <p:sp>
           <p:nvSpPr>
-            <p:cNvPr id="135" name="TextBox 17"/>
+            <p:cNvPr id="154" name="TextBox 17"/>
             <p:cNvSpPr/>
             <p:nvPr/>
           </p:nvSpPr>
@@ -8162,7 +9132,7 @@
       </p:grpSp>
       <p:grpSp>
         <p:nvGrpSpPr>
-          <p:cNvPr id="136" name="c1"/>
+          <p:cNvPr id="155" name="c1"/>
           <p:cNvGrpSpPr/>
           <p:nvPr/>
         </p:nvGrpSpPr>
@@ -8176,7 +9146,7 @@
         </p:grpSpPr>
         <p:sp>
           <p:nvSpPr>
-            <p:cNvPr id="137" name="Freeform 19"/>
+            <p:cNvPr id="156" name="Freeform 19"/>
             <p:cNvSpPr/>
             <p:nvPr/>
           </p:nvSpPr>
@@ -8219,7 +9189,7 @@
         </p:sp>
         <p:sp>
           <p:nvSpPr>
-            <p:cNvPr id="138" name="Freeform 20"/>
+            <p:cNvPr id="157" name="Freeform 20"/>
             <p:cNvSpPr/>
             <p:nvPr/>
           </p:nvSpPr>
@@ -8265,7 +9235,7 @@
         </p:sp>
         <p:sp>
           <p:nvSpPr>
-            <p:cNvPr id="139" name="TextBox 21"/>
+            <p:cNvPr id="158" name="TextBox 21"/>
             <p:cNvSpPr/>
             <p:nvPr/>
           </p:nvSpPr>
@@ -8319,7 +9289,7 @@
         </p:sp>
         <p:sp>
           <p:nvSpPr>
-            <p:cNvPr id="140" name="TextBox 22"/>
+            <p:cNvPr id="159" name="TextBox 22"/>
             <p:cNvSpPr/>
             <p:nvPr/>
           </p:nvSpPr>
@@ -8373,7 +9343,7 @@
         </p:sp>
         <p:sp>
           <p:nvSpPr>
-            <p:cNvPr id="141" name="TextBox 23"/>
+            <p:cNvPr id="160" name="TextBox 23"/>
             <p:cNvSpPr/>
             <p:nvPr/>
           </p:nvSpPr>
@@ -8427,7 +9397,7 @@
         </p:sp>
         <p:grpSp>
           <p:nvGrpSpPr>
-            <p:cNvPr id="142" name="Group 26"/>
+            <p:cNvPr id="161" name="Group 26"/>
             <p:cNvGrpSpPr/>
             <p:nvPr/>
           </p:nvGrpSpPr>
@@ -8441,7 +9411,7 @@
           </p:grpSpPr>
           <p:sp>
             <p:nvSpPr>
-              <p:cNvPr id="143" name="Line 24"/>
+              <p:cNvPr id="162" name="Line 24"/>
               <p:cNvSpPr/>
               <p:nvPr/>
             </p:nvSpPr>
@@ -8483,7 +9453,7 @@
           </p:sp>
           <p:sp>
             <p:nvSpPr>
-              <p:cNvPr id="144" name="Line 25"/>
+              <p:cNvPr id="163" name="Line 25"/>
               <p:cNvSpPr/>
               <p:nvPr/>
             </p:nvSpPr>
@@ -8527,7 +9497,7 @@
       </p:grpSp>
       <p:grpSp>
         <p:nvGrpSpPr>
-          <p:cNvPr id="145" name="branch-claude"/>
+          <p:cNvPr id="164" name="branch-claude"/>
           <p:cNvGrpSpPr/>
           <p:nvPr/>
         </p:nvGrpSpPr>
@@ -8541,7 +9511,7 @@
         </p:grpSpPr>
         <p:sp>
           <p:nvSpPr>
-            <p:cNvPr id="146" name="Rectangle 28"/>
+            <p:cNvPr id="165" name="Rectangle 28"/>
             <p:cNvSpPr/>
             <p:nvPr/>
           </p:nvSpPr>
@@ -8584,7 +9554,7 @@
         </p:sp>
         <p:sp>
           <p:nvSpPr>
-            <p:cNvPr id="147" name="Rectangle 29"/>
+            <p:cNvPr id="166" name="Rectangle 29"/>
             <p:cNvSpPr/>
             <p:nvPr/>
           </p:nvSpPr>
@@ -8630,7 +9600,7 @@
         </p:sp>
         <p:sp>
           <p:nvSpPr>
-            <p:cNvPr id="148" name="Freeform 30"/>
+            <p:cNvPr id="167" name="Freeform 30"/>
             <p:cNvSpPr/>
             <p:nvPr/>
           </p:nvSpPr>
@@ -8728,7 +9698,7 @@
         </p:sp>
         <p:sp>
           <p:nvSpPr>
-            <p:cNvPr id="149" name="TextBox 31"/>
+            <p:cNvPr id="168" name="TextBox 31"/>
             <p:cNvSpPr/>
             <p:nvPr/>
           </p:nvSpPr>
@@ -8782,7 +9752,7 @@
         </p:sp>
         <p:sp>
           <p:nvSpPr>
-            <p:cNvPr id="150" name="TextBox 32"/>
+            <p:cNvPr id="169" name="TextBox 32"/>
             <p:cNvSpPr/>
             <p:nvPr/>
           </p:nvSpPr>
@@ -8837,7 +9807,7 @@
       </p:grpSp>
       <p:grpSp>
         <p:nvGrpSpPr>
-          <p:cNvPr id="151" name="branch-qwen"/>
+          <p:cNvPr id="170" name="branch-qwen"/>
           <p:cNvGrpSpPr/>
           <p:nvPr/>
         </p:nvGrpSpPr>
@@ -8851,7 +9821,7 @@
         </p:grpSpPr>
         <p:sp>
           <p:nvSpPr>
-            <p:cNvPr id="152" name="Rectangle 34"/>
+            <p:cNvPr id="171" name="Rectangle 34"/>
             <p:cNvSpPr/>
             <p:nvPr/>
           </p:nvSpPr>
@@ -8894,7 +9864,7 @@
         </p:sp>
         <p:sp>
           <p:nvSpPr>
-            <p:cNvPr id="153" name="Rectangle 35"/>
+            <p:cNvPr id="172" name="Rectangle 35"/>
             <p:cNvSpPr/>
             <p:nvPr/>
           </p:nvSpPr>
@@ -8940,7 +9910,7 @@
         </p:sp>
         <p:grpSp>
           <p:nvGrpSpPr>
-            <p:cNvPr id="154" name="Group 40"/>
+            <p:cNvPr id="173" name="Group 40"/>
             <p:cNvGrpSpPr/>
             <p:nvPr/>
           </p:nvGrpSpPr>
@@ -8954,7 +9924,7 @@
           </p:grpSpPr>
           <p:sp>
             <p:nvSpPr>
-              <p:cNvPr id="155" name="Freeform 36"/>
+              <p:cNvPr id="174" name="Freeform 36"/>
               <p:cNvSpPr/>
               <p:nvPr/>
             </p:nvSpPr>
@@ -9043,7 +10013,7 @@
           </p:sp>
           <p:sp>
             <p:nvSpPr>
-              <p:cNvPr id="156" name="Freeform 37"/>
+              <p:cNvPr id="175" name="Freeform 37"/>
               <p:cNvSpPr/>
               <p:nvPr/>
             </p:nvSpPr>
@@ -9103,7 +10073,7 @@
           </p:sp>
           <p:sp>
             <p:nvSpPr>
-              <p:cNvPr id="157" name="Freeform 38"/>
+              <p:cNvPr id="176" name="Freeform 38"/>
               <p:cNvSpPr/>
               <p:nvPr/>
             </p:nvSpPr>
@@ -9163,7 +10133,7 @@
           </p:sp>
           <p:sp>
             <p:nvSpPr>
-              <p:cNvPr id="158" name="Freeform 39"/>
+              <p:cNvPr id="177" name="Freeform 39"/>
               <p:cNvSpPr/>
               <p:nvPr/>
             </p:nvSpPr>
@@ -9224,7 +10194,7 @@
         </p:grpSp>
         <p:sp>
           <p:nvSpPr>
-            <p:cNvPr id="159" name="TextBox 41"/>
+            <p:cNvPr id="178" name="TextBox 41"/>
             <p:cNvSpPr/>
             <p:nvPr/>
           </p:nvSpPr>
@@ -9278,7 +10248,7 @@
         </p:sp>
         <p:sp>
           <p:nvSpPr>
-            <p:cNvPr id="160" name="TextBox 42"/>
+            <p:cNvPr id="179" name="TextBox 42"/>
             <p:cNvSpPr/>
             <p:nvPr/>
           </p:nvSpPr>
@@ -9332,7 +10302,7 @@
         </p:sp>
         <p:sp>
           <p:nvSpPr>
-            <p:cNvPr id="161" name="TextBox 45"/>
+            <p:cNvPr id="180" name="TextBox 45"/>
             <p:cNvSpPr/>
             <p:nvPr/>
           </p:nvSpPr>
@@ -9397,7 +10367,7 @@
       </p:grpSp>
       <p:grpSp>
         <p:nvGrpSpPr>
-          <p:cNvPr id="162" name="shared-evidence"/>
+          <p:cNvPr id="181" name="shared-evidence"/>
           <p:cNvGrpSpPr/>
           <p:nvPr/>
         </p:nvGrpSpPr>
@@ -9411,7 +10381,7 @@
         </p:grpSpPr>
         <p:sp>
           <p:nvSpPr>
-            <p:cNvPr id="163" name="Freeform 47"/>
+            <p:cNvPr id="182" name="Freeform 47"/>
             <p:cNvSpPr/>
             <p:nvPr/>
           </p:nvSpPr>
@@ -9456,7 +10426,7 @@
         </p:sp>
         <p:sp>
           <p:nvSpPr>
-            <p:cNvPr id="164" name="Rectangle 48"/>
+            <p:cNvPr id="183" name="Rectangle 48"/>
             <p:cNvSpPr/>
             <p:nvPr/>
           </p:nvSpPr>
@@ -9499,7 +10469,7 @@
         </p:sp>
         <p:sp>
           <p:nvSpPr>
-            <p:cNvPr id="165" name="Rectangle 49"/>
+            <p:cNvPr id="184" name="Rectangle 49"/>
             <p:cNvSpPr/>
             <p:nvPr/>
           </p:nvSpPr>
@@ -9545,7 +10515,7 @@
         </p:sp>
         <p:sp>
           <p:nvSpPr>
-            <p:cNvPr id="166" name="TextBox 50"/>
+            <p:cNvPr id="185" name="TextBox 50"/>
             <p:cNvSpPr/>
             <p:nvPr/>
           </p:nvSpPr>
@@ -9599,7 +10569,7 @@
         </p:sp>
         <p:sp>
           <p:nvSpPr>
-            <p:cNvPr id="167" name="Freeform 51"/>
+            <p:cNvPr id="186" name="Freeform 51"/>
             <p:cNvSpPr/>
             <p:nvPr/>
           </p:nvSpPr>
@@ -9662,7 +10632,7 @@
         </p:sp>
         <p:sp>
           <p:nvSpPr>
-            <p:cNvPr id="168" name="TextBox 52"/>
+            <p:cNvPr id="187" name="TextBox 52"/>
             <p:cNvSpPr/>
             <p:nvPr/>
           </p:nvSpPr>
@@ -9729,7 +10699,7 @@
         </p:sp>
         <p:sp>
           <p:nvSpPr>
-            <p:cNvPr id="169" name="Line 53"/>
+            <p:cNvPr id="188" name="Line 53"/>
             <p:cNvSpPr/>
             <p:nvPr/>
           </p:nvSpPr>
@@ -9789,7 +10759,7 @@
         </p:sp>
         <p:sp>
           <p:nvSpPr>
-            <p:cNvPr id="170" name="Freeform 54"/>
+            <p:cNvPr id="189" name="Freeform 54"/>
             <p:cNvSpPr/>
             <p:nvPr/>
           </p:nvSpPr>
@@ -9852,7 +10822,7 @@
         </p:sp>
         <p:sp>
           <p:nvSpPr>
-            <p:cNvPr id="171" name="TextBox 55"/>
+            <p:cNvPr id="190" name="TextBox 55"/>
             <p:cNvSpPr/>
             <p:nvPr/>
           </p:nvSpPr>
@@ -9906,7 +10876,7 @@
         </p:sp>
         <p:sp>
           <p:nvSpPr>
-            <p:cNvPr id="172" name="TextBox 56"/>
+            <p:cNvPr id="191" name="TextBox 56"/>
             <p:cNvSpPr/>
             <p:nvPr/>
           </p:nvSpPr>
@@ -9970,7 +10940,7 @@
         </p:sp>
         <p:sp>
           <p:nvSpPr>
-            <p:cNvPr id="173" name="TextBox 57"/>
+            <p:cNvPr id="192" name="TextBox 57"/>
             <p:cNvSpPr/>
             <p:nvPr/>
           </p:nvSpPr>
@@ -10025,7 +10995,7 @@
       </p:grpSp>
       <p:grpSp>
         <p:nvGrpSpPr>
-          <p:cNvPr id="174" name="tool-roles"/>
+          <p:cNvPr id="193" name="tool-roles"/>
           <p:cNvGrpSpPr/>
           <p:nvPr/>
         </p:nvGrpSpPr>
@@ -10039,7 +11009,7 @@
         </p:grpSpPr>
         <p:grpSp>
           <p:nvGrpSpPr>
-            <p:cNvPr id="175" name="Group 63"/>
+            <p:cNvPr id="194" name="Group 63"/>
             <p:cNvGrpSpPr/>
             <p:nvPr/>
           </p:nvGrpSpPr>
@@ -10053,7 +11023,7 @@
           </p:grpSpPr>
           <p:sp>
             <p:nvSpPr>
-              <p:cNvPr id="176" name="Rectangle 59"/>
+              <p:cNvPr id="195" name="Rectangle 59"/>
               <p:cNvSpPr/>
               <p:nvPr/>
             </p:nvSpPr>
@@ -10099,7 +11069,7 @@
           </p:sp>
           <p:sp>
             <p:nvSpPr>
-              <p:cNvPr id="177" name="Rectangle 60"/>
+              <p:cNvPr id="196" name="Rectangle 60"/>
               <p:cNvSpPr/>
               <p:nvPr/>
             </p:nvSpPr>
@@ -10145,7 +11115,7 @@
           </p:sp>
           <p:sp>
             <p:nvSpPr>
-              <p:cNvPr id="178" name="Rectangle 61"/>
+              <p:cNvPr id="197" name="Rectangle 61"/>
               <p:cNvSpPr/>
               <p:nvPr/>
             </p:nvSpPr>
@@ -10191,7 +11161,7 @@
           </p:sp>
           <p:sp>
             <p:nvSpPr>
-              <p:cNvPr id="179" name="Rectangle 62"/>
+              <p:cNvPr id="198" name="Rectangle 62"/>
               <p:cNvSpPr/>
               <p:nvPr/>
             </p:nvSpPr>
@@ -10238,7 +11208,7 @@
         </p:grpSp>
         <p:grpSp>
           <p:nvGrpSpPr>
-            <p:cNvPr id="180" name="Group 72"/>
+            <p:cNvPr id="199" name="Group 72"/>
             <p:cNvGrpSpPr/>
             <p:nvPr/>
           </p:nvGrpSpPr>
@@ -10252,7 +11222,7 @@
           </p:grpSpPr>
           <p:sp>
             <p:nvSpPr>
-              <p:cNvPr id="181" name="TextBox 64"/>
+              <p:cNvPr id="200" name="TextBox 64"/>
               <p:cNvSpPr/>
               <p:nvPr/>
             </p:nvSpPr>
@@ -10306,7 +11276,7 @@
           </p:sp>
           <p:sp>
             <p:nvSpPr>
-              <p:cNvPr id="182" name="TextBox 65"/>
+              <p:cNvPr id="201" name="TextBox 65"/>
               <p:cNvSpPr/>
               <p:nvPr/>
             </p:nvSpPr>
@@ -10360,7 +11330,7 @@
           </p:sp>
           <p:sp>
             <p:nvSpPr>
-              <p:cNvPr id="183" name="TextBox 66"/>
+              <p:cNvPr id="202" name="TextBox 66"/>
               <p:cNvSpPr/>
               <p:nvPr/>
             </p:nvSpPr>
@@ -10414,7 +11384,7 @@
           </p:sp>
           <p:sp>
             <p:nvSpPr>
-              <p:cNvPr id="184" name="TextBox 67"/>
+              <p:cNvPr id="203" name="TextBox 67"/>
               <p:cNvSpPr/>
               <p:nvPr/>
             </p:nvSpPr>
@@ -10468,7 +11438,7 @@
           </p:sp>
           <p:sp>
             <p:nvSpPr>
-              <p:cNvPr id="185" name="TextBox 68"/>
+              <p:cNvPr id="204" name="TextBox 68"/>
               <p:cNvSpPr/>
               <p:nvPr/>
             </p:nvSpPr>
@@ -10522,7 +11492,7 @@
           </p:sp>
           <p:sp>
             <p:nvSpPr>
-              <p:cNvPr id="186" name="TextBox 69"/>
+              <p:cNvPr id="205" name="TextBox 69"/>
               <p:cNvSpPr/>
               <p:nvPr/>
             </p:nvSpPr>
@@ -10576,7 +11546,7 @@
           </p:sp>
           <p:sp>
             <p:nvSpPr>
-              <p:cNvPr id="187" name="TextBox 70"/>
+              <p:cNvPr id="206" name="TextBox 70"/>
               <p:cNvSpPr/>
               <p:nvPr/>
             </p:nvSpPr>
@@ -10630,7 +11600,7 @@
           </p:sp>
           <p:sp>
             <p:nvSpPr>
-              <p:cNvPr id="188" name="TextBox 71"/>
+              <p:cNvPr id="207" name="TextBox 71"/>
               <p:cNvSpPr/>
               <p:nvPr/>
             </p:nvSpPr>
@@ -10732,7 +11702,7 @@
                                           </p:stCondLst>
                                         </p:cTn>
                                         <p:tgtEl>
-                                          <p:spTgt spid="145"/>
+                                          <p:spTgt spid="164"/>
                                         </p:tgtEl>
                                         <p:attrNameLst>
                                           <p:attrName>style.visibility</p:attrName>
@@ -10746,7 +11716,7 @@
                                       <p:cBhvr additive="repl">
                                         <p:cTn id="29" dur="500"/>
                                         <p:tgtEl>
-                                          <p:spTgt spid="145"/>
+                                          <p:spTgt spid="164"/>
                                         </p:tgtEl>
                                       </p:cBhvr>
                                     </p:animEffect>
@@ -10785,7 +11755,7 @@
                                           </p:stCondLst>
                                         </p:cTn>
                                         <p:tgtEl>
-                                          <p:spTgt spid="151"/>
+                                          <p:spTgt spid="170"/>
                                         </p:tgtEl>
                                         <p:attrNameLst>
                                           <p:attrName>style.visibility</p:attrName>
@@ -10799,7 +11769,7 @@
                                       <p:cBhvr additive="repl">
                                         <p:cTn id="34" dur="500"/>
                                         <p:tgtEl>
-                                          <p:spTgt spid="151"/>
+                                          <p:spTgt spid="170"/>
                                         </p:tgtEl>
                                       </p:cBhvr>
                                     </p:animEffect>
@@ -10838,7 +11808,7 @@
                                           </p:stCondLst>
                                         </p:cTn>
                                         <p:tgtEl>
-                                          <p:spTgt spid="162"/>
+                                          <p:spTgt spid="181"/>
                                         </p:tgtEl>
                                         <p:attrNameLst>
                                           <p:attrName>style.visibility</p:attrName>
@@ -10852,7 +11822,7 @@
                                       <p:cBhvr additive="repl">
                                         <p:cTn id="39" dur="600"/>
                                         <p:tgtEl>
-                                          <p:spTgt spid="162"/>
+                                          <p:spTgt spid="181"/>
                                         </p:tgtEl>
                                       </p:cBhvr>
                                     </p:animEffect>
@@ -10916,7 +11886,7 @@
       </p:grpSpPr>
       <p:grpSp>
         <p:nvGrpSpPr>
-          <p:cNvPr id="189" name="title"/>
+          <p:cNvPr id="208" name="title"/>
           <p:cNvGrpSpPr/>
           <p:nvPr/>
         </p:nvGrpSpPr>
@@ -10930,7 +11900,7 @@
         </p:grpSpPr>
         <p:sp>
           <p:nvSpPr>
-            <p:cNvPr id="190" name="TextBox 6"/>
+            <p:cNvPr id="209" name="TextBox 6"/>
             <p:cNvSpPr/>
             <p:nvPr/>
           </p:nvSpPr>
@@ -10985,7 +11955,7 @@
       </p:grpSp>
       <p:grpSp>
         <p:nvGrpSpPr>
-          <p:cNvPr id="191" name="shared-start"/>
+          <p:cNvPr id="210" name="shared-start"/>
           <p:cNvGrpSpPr/>
           <p:nvPr/>
         </p:nvGrpSpPr>
@@ -10999,7 +11969,7 @@
         </p:grpSpPr>
         <p:sp>
           <p:nvSpPr>
-            <p:cNvPr id="192" name="Rectangle 8"/>
+            <p:cNvPr id="211" name="Rectangle 8"/>
             <p:cNvSpPr/>
             <p:nvPr/>
           </p:nvSpPr>
@@ -11045,7 +12015,7 @@
         </p:sp>
         <p:sp>
           <p:nvSpPr>
-            <p:cNvPr id="193" name="Freeform 9"/>
+            <p:cNvPr id="212" name="Freeform 9"/>
             <p:cNvSpPr/>
             <p:nvPr/>
           </p:nvSpPr>
@@ -11108,7 +12078,7 @@
         </p:sp>
         <p:sp>
           <p:nvSpPr>
-            <p:cNvPr id="194" name="TextBox 10"/>
+            <p:cNvPr id="213" name="TextBox 10"/>
             <p:cNvSpPr/>
             <p:nvPr/>
           </p:nvSpPr>
@@ -11162,7 +12132,7 @@
         </p:sp>
         <p:sp>
           <p:nvSpPr>
-            <p:cNvPr id="195" name="TextBox 11"/>
+            <p:cNvPr id="214" name="TextBox 11"/>
             <p:cNvSpPr/>
             <p:nvPr/>
           </p:nvSpPr>
@@ -11217,7 +12187,7 @@
       </p:grpSp>
       <p:grpSp>
         <p:nvGrpSpPr>
-          <p:cNvPr id="196" name="growth-qwen"/>
+          <p:cNvPr id="215" name="growth-qwen"/>
           <p:cNvGrpSpPr/>
           <p:nvPr/>
         </p:nvGrpSpPr>
@@ -11231,7 +12201,7 @@
         </p:grpSpPr>
         <p:sp>
           <p:nvSpPr>
-            <p:cNvPr id="197" name="Rectangle 13"/>
+            <p:cNvPr id="216" name="Rectangle 13"/>
             <p:cNvSpPr/>
             <p:nvPr/>
           </p:nvSpPr>
@@ -11274,7 +12244,7 @@
         </p:sp>
         <p:sp>
           <p:nvSpPr>
-            <p:cNvPr id="198" name="Rectangle 14"/>
+            <p:cNvPr id="217" name="Rectangle 14"/>
             <p:cNvSpPr/>
             <p:nvPr/>
           </p:nvSpPr>
@@ -11320,7 +12290,7 @@
         </p:sp>
         <p:sp>
           <p:nvSpPr>
-            <p:cNvPr id="199" name="TextBox 15"/>
+            <p:cNvPr id="218" name="TextBox 15"/>
             <p:cNvSpPr/>
             <p:nvPr/>
           </p:nvSpPr>
@@ -11374,7 +12344,7 @@
         </p:sp>
         <p:sp>
           <p:nvSpPr>
-            <p:cNvPr id="200" name="TextBox 16"/>
+            <p:cNvPr id="219" name="TextBox 16"/>
             <p:cNvSpPr/>
             <p:nvPr/>
           </p:nvSpPr>
@@ -11428,7 +12398,7 @@
         </p:sp>
         <p:sp>
           <p:nvSpPr>
-            <p:cNvPr id="201" name="TextBox 17"/>
+            <p:cNvPr id="220" name="TextBox 17"/>
             <p:cNvSpPr/>
             <p:nvPr/>
           </p:nvSpPr>
@@ -11483,7 +12453,7 @@
       </p:grpSp>
       <p:grpSp>
         <p:nvGrpSpPr>
-          <p:cNvPr id="202" name="growth-claude"/>
+          <p:cNvPr id="221" name="growth-claude"/>
           <p:cNvGrpSpPr/>
           <p:nvPr/>
         </p:nvGrpSpPr>
@@ -11497,7 +12467,7 @@
         </p:grpSpPr>
         <p:sp>
           <p:nvSpPr>
-            <p:cNvPr id="203" name="Rectangle 19"/>
+            <p:cNvPr id="222" name="Rectangle 19"/>
             <p:cNvSpPr/>
             <p:nvPr/>
           </p:nvSpPr>
@@ -11540,7 +12510,7 @@
         </p:sp>
         <p:sp>
           <p:nvSpPr>
-            <p:cNvPr id="204" name="Rectangle 20"/>
+            <p:cNvPr id="223" name="Rectangle 20"/>
             <p:cNvSpPr/>
             <p:nvPr/>
           </p:nvSpPr>
@@ -11586,7 +12556,7 @@
         </p:sp>
         <p:sp>
           <p:nvSpPr>
-            <p:cNvPr id="205" name="TextBox 21"/>
+            <p:cNvPr id="224" name="TextBox 21"/>
             <p:cNvSpPr/>
             <p:nvPr/>
           </p:nvSpPr>
@@ -11640,7 +12610,7 @@
         </p:sp>
         <p:sp>
           <p:nvSpPr>
-            <p:cNvPr id="206" name="TextBox 22"/>
+            <p:cNvPr id="225" name="TextBox 22"/>
             <p:cNvSpPr/>
             <p:nvPr/>
           </p:nvSpPr>
@@ -11694,7 +12664,7 @@
         </p:sp>
         <p:sp>
           <p:nvSpPr>
-            <p:cNvPr id="207" name="TextBox 23"/>
+            <p:cNvPr id="226" name="TextBox 23"/>
             <p:cNvSpPr/>
             <p:nvPr/>
           </p:nvSpPr>
@@ -11762,7 +12732,7 @@
       </p:grpSp>
       <p:sp>
         <p:nvSpPr>
-          <p:cNvPr id="208" name="TextBox 25"/>
+          <p:cNvPr id="227" name="TextBox 25"/>
           <p:cNvSpPr/>
           <p:nvPr/>
         </p:nvSpPr>
@@ -11816,7 +12786,7 @@
       </p:sp>
       <p:sp>
         <p:nvSpPr>
-          <p:cNvPr id="209" name="Freeform 26"/>
+          <p:cNvPr id="228" name="Freeform 26"/>
           <p:cNvSpPr/>
           <p:nvPr/>
         </p:nvSpPr>
@@ -11859,7 +12829,7 @@
       </p:sp>
       <p:sp>
         <p:nvSpPr>
-          <p:cNvPr id="210" name="Freeform 27"/>
+          <p:cNvPr id="229" name="Freeform 27"/>
           <p:cNvSpPr/>
           <p:nvPr/>
         </p:nvSpPr>
@@ -11905,7 +12875,7 @@
       </p:sp>
       <p:sp>
         <p:nvSpPr>
-          <p:cNvPr id="211" name="Freeform 28"/>
+          <p:cNvPr id="230" name="Freeform 28"/>
           <p:cNvSpPr/>
           <p:nvPr/>
         </p:nvSpPr>
@@ -11949,7 +12919,7 @@
       </p:sp>
       <p:sp>
         <p:nvSpPr>
-          <p:cNvPr id="212" name="Freeform 29"/>
+          <p:cNvPr id="231" name="Freeform 29"/>
           <p:cNvSpPr/>
           <p:nvPr/>
         </p:nvSpPr>
@@ -11992,7 +12962,7 @@
       </p:sp>
       <p:sp>
         <p:nvSpPr>
-          <p:cNvPr id="213" name="Freeform 30"/>
+          <p:cNvPr id="232" name="Freeform 30"/>
           <p:cNvSpPr/>
           <p:nvPr/>
         </p:nvSpPr>
@@ -12038,7 +13008,7 @@
       </p:sp>
       <p:sp>
         <p:nvSpPr>
-          <p:cNvPr id="214" name="Freeform 31"/>
+          <p:cNvPr id="233" name="Freeform 31"/>
           <p:cNvSpPr/>
           <p:nvPr/>
         </p:nvSpPr>
@@ -12083,7 +13053,7 @@
       </p:sp>
       <p:sp>
         <p:nvSpPr>
-          <p:cNvPr id="215" name="TextBox 32"/>
+          <p:cNvPr id="234" name="TextBox 32"/>
           <p:cNvSpPr/>
           <p:nvPr/>
         </p:nvSpPr>
@@ -12137,7 +13107,7 @@
       </p:sp>
       <p:grpSp>
         <p:nvGrpSpPr>
-          <p:cNvPr id="216" name="Group 37"/>
+          <p:cNvPr id="235" name="Group 37"/>
           <p:cNvGrpSpPr/>
           <p:nvPr/>
         </p:nvGrpSpPr>
@@ -12151,7 +13121,7 @@
         </p:grpSpPr>
         <p:sp>
           <p:nvSpPr>
-            <p:cNvPr id="217" name="TextBox 33"/>
+            <p:cNvPr id="236" name="TextBox 33"/>
             <p:cNvSpPr/>
             <p:nvPr/>
           </p:nvSpPr>
@@ -12205,7 +13175,7 @@
         </p:sp>
         <p:sp>
           <p:nvSpPr>
-            <p:cNvPr id="218" name="TextBox 34"/>
+            <p:cNvPr id="237" name="TextBox 34"/>
             <p:cNvSpPr/>
             <p:nvPr/>
           </p:nvSpPr>
@@ -12259,7 +13229,7 @@
         </p:sp>
         <p:sp>
           <p:nvSpPr>
-            <p:cNvPr id="219" name="TextBox 35"/>
+            <p:cNvPr id="238" name="TextBox 35"/>
             <p:cNvSpPr/>
             <p:nvPr/>
           </p:nvSpPr>
@@ -12313,7 +13283,7 @@
         </p:sp>
         <p:sp>
           <p:nvSpPr>
-            <p:cNvPr id="220" name="TextBox 36"/>
+            <p:cNvPr id="239" name="TextBox 36"/>
             <p:cNvSpPr/>
             <p:nvPr/>
           </p:nvSpPr>
@@ -12368,7 +13338,7 @@
       </p:grpSp>
       <p:grpSp>
         <p:nvGrpSpPr>
-          <p:cNvPr id="221" name="Group 40"/>
+          <p:cNvPr id="240" name="Group 40"/>
           <p:cNvGrpSpPr/>
           <p:nvPr/>
         </p:nvGrpSpPr>
@@ -12382,7 +13352,7 @@
         </p:grpSpPr>
         <p:sp>
           <p:nvSpPr>
-            <p:cNvPr id="222" name="TextBox 38"/>
+            <p:cNvPr id="241" name="TextBox 38"/>
             <p:cNvSpPr/>
             <p:nvPr/>
           </p:nvSpPr>
@@ -12436,7 +13406,7 @@
         </p:sp>
         <p:sp>
           <p:nvSpPr>
-            <p:cNvPr id="223" name="TextBox 39"/>
+            <p:cNvPr id="242" name="TextBox 39"/>
             <p:cNvSpPr/>
             <p:nvPr/>
           </p:nvSpPr>
@@ -12491,7 +13461,7 @@
       </p:grpSp>
       <p:grpSp>
         <p:nvGrpSpPr>
-          <p:cNvPr id="224" name="Group 44"/>
+          <p:cNvPr id="243" name="Group 44"/>
           <p:cNvGrpSpPr/>
           <p:nvPr/>
         </p:nvGrpSpPr>
@@ -12505,7 +13475,7 @@
         </p:grpSpPr>
         <p:sp>
           <p:nvSpPr>
-            <p:cNvPr id="225" name="TextBox 41"/>
+            <p:cNvPr id="244" name="TextBox 41"/>
             <p:cNvSpPr/>
             <p:nvPr/>
           </p:nvSpPr>
@@ -12559,7 +13529,7 @@
         </p:sp>
         <p:sp>
           <p:nvSpPr>
-            <p:cNvPr id="226" name="TextBox 42"/>
+            <p:cNvPr id="245" name="TextBox 42"/>
             <p:cNvSpPr/>
             <p:nvPr/>
           </p:nvSpPr>
@@ -12613,7 +13583,7 @@
         </p:sp>
         <p:sp>
           <p:nvSpPr>
-            <p:cNvPr id="227" name="TextBox 43"/>
+            <p:cNvPr id="246" name="TextBox 43"/>
             <p:cNvSpPr/>
             <p:nvPr/>
           </p:nvSpPr>
@@ -12678,432 +13648,7 @@
       </p:grpSp>
       <p:grpSp>
         <p:nvGrpSpPr>
-          <p:cNvPr id="228" name="pbe0-result"/>
-          <p:cNvGrpSpPr/>
-          <p:nvPr/>
-        </p:nvGrpSpPr>
-        <p:grpSpPr>
-          <a:xfrm>
-            <a:off x="6477120" y="4952880"/>
-            <a:ext cx="5105160" cy="590040"/>
-            <a:chOff x="6477120" y="4952880"/>
-            <a:chExt cx="5105160" cy="590040"/>
-          </a:xfrm>
-        </p:grpSpPr>
-        <p:sp>
-          <p:nvSpPr>
-            <p:cNvPr id="229" name="Rectangle 46"/>
-            <p:cNvSpPr/>
-            <p:nvPr/>
-          </p:nvSpPr>
-          <p:spPr>
-            <a:xfrm>
-              <a:off x="6477120" y="4952880"/>
-              <a:ext cx="5105160" cy="590040"/>
-            </a:xfrm>
-            <a:prstGeom prst="roundRect">
-              <a:avLst>
-                <a:gd name="adj" fmla="val 22581"/>
-              </a:avLst>
-            </a:prstGeom>
-            <a:solidFill>
-              <a:schemeClr val="lt2"/>
-            </a:solidFill>
-            <a:ln w="28440">
-              <a:solidFill>
-                <a:schemeClr val="accent1"/>
-              </a:solidFill>
-              <a:custDash>
-                <a:ds d="333000" sp="266000"/>
-              </a:custDash>
-              <a:round/>
-            </a:ln>
-          </p:spPr>
-          <p:style>
-            <a:lnRef idx="0"/>
-            <a:fillRef idx="0"/>
-            <a:effectRef idx="0"/>
-            <a:fontRef idx="minor"/>
-          </p:style>
-          <p:txBody>
-            <a:bodyPr lIns="90000" rIns="90000" tIns="45000" bIns="45000" anchor="t">
-              <a:noAutofit/>
-            </a:bodyPr>
-            <a:p>
-              <a:endParaRPr b="0" lang="en-GB" sz="1800" spc="-1" strike="noStrike">
-                <a:solidFill>
-                  <a:srgbClr val="000000"/>
-                </a:solidFill>
-                <a:latin typeface="Arial"/>
-              </a:endParaRPr>
-            </a:p>
-          </p:txBody>
-        </p:sp>
-        <p:grpSp>
-          <p:nvGrpSpPr>
-            <p:cNvPr id="230" name="Group 51"/>
-            <p:cNvGrpSpPr/>
-            <p:nvPr/>
-          </p:nvGrpSpPr>
-          <p:grpSpPr>
-            <a:xfrm>
-              <a:off x="6734160" y="5110200"/>
-              <a:ext cx="171000" cy="256680"/>
-              <a:chOff x="6734160" y="5110200"/>
-              <a:chExt cx="171000" cy="256680"/>
-            </a:xfrm>
-          </p:grpSpPr>
-          <p:sp>
-            <p:nvSpPr>
-              <p:cNvPr id="231" name="Freeform 47"/>
-              <p:cNvSpPr/>
-              <p:nvPr/>
-            </p:nvSpPr>
-            <p:spPr>
-              <a:xfrm>
-                <a:off x="6741360" y="5167440"/>
-                <a:ext cx="156960" cy="9000"/>
-              </a:xfrm>
-              <a:custGeom>
-                <a:avLst/>
-                <a:gdLst>
-                  <a:gd name="textAreaLeft" fmla="*/ 0 w 156960"/>
-                  <a:gd name="textAreaRight" fmla="*/ 157320 w 156960"/>
-                  <a:gd name="textAreaTop" fmla="*/ 0 h 9000"/>
-                  <a:gd name="textAreaBottom" fmla="*/ 9360 h 9000"/>
-                </a:gdLst>
-                <a:ahLst/>
-                <a:rect l="textAreaLeft" t="textAreaTop" r="textAreaRight" b="textAreaBottom"/>
-                <a:pathLst>
-                  <a:path w="157162" h="9525">
-                    <a:moveTo>
-                      <a:pt x="0" y="0"/>
-                    </a:moveTo>
-                    <a:lnTo>
-                      <a:pt x="157162" y="0"/>
-                    </a:lnTo>
-                  </a:path>
-                </a:pathLst>
-              </a:custGeom>
-              <a:noFill/>
-              <a:ln w="28440">
-                <a:solidFill>
-                  <a:schemeClr val="accent1"/>
-                </a:solidFill>
-                <a:round/>
-              </a:ln>
-            </p:spPr>
-            <p:style>
-              <a:lnRef idx="0"/>
-              <a:fillRef idx="0"/>
-              <a:effectRef idx="0"/>
-              <a:fontRef idx="minor"/>
-            </p:style>
-            <p:txBody>
-              <a:bodyPr lIns="90000" rIns="90000" tIns="-35640" bIns="-35640" anchor="t">
-                <a:noAutofit/>
-              </a:bodyPr>
-              <a:p>
-                <a:endParaRPr b="0" lang="en-GB" sz="1800" spc="-1" strike="noStrike">
-                  <a:solidFill>
-                    <a:srgbClr val="000000"/>
-                  </a:solidFill>
-                  <a:latin typeface="Arial"/>
-                </a:endParaRPr>
-              </a:p>
-            </p:txBody>
-          </p:sp>
-          <p:sp>
-            <p:nvSpPr>
-              <p:cNvPr id="232" name="Freeform 48"/>
-              <p:cNvSpPr/>
-              <p:nvPr/>
-            </p:nvSpPr>
-            <p:spPr>
-              <a:xfrm>
-                <a:off x="6741360" y="5310360"/>
-                <a:ext cx="156960" cy="9000"/>
-              </a:xfrm>
-              <a:custGeom>
-                <a:avLst/>
-                <a:gdLst>
-                  <a:gd name="textAreaLeft" fmla="*/ 0 w 156960"/>
-                  <a:gd name="textAreaRight" fmla="*/ 157320 w 156960"/>
-                  <a:gd name="textAreaTop" fmla="*/ 0 h 9000"/>
-                  <a:gd name="textAreaBottom" fmla="*/ 9360 h 9000"/>
-                </a:gdLst>
-                <a:ahLst/>
-                <a:rect l="textAreaLeft" t="textAreaTop" r="textAreaRight" b="textAreaBottom"/>
-                <a:pathLst>
-                  <a:path w="157162" h="9525">
-                    <a:moveTo>
-                      <a:pt x="0" y="0"/>
-                    </a:moveTo>
-                    <a:lnTo>
-                      <a:pt x="157162" y="0"/>
-                    </a:lnTo>
-                  </a:path>
-                </a:pathLst>
-              </a:custGeom>
-              <a:noFill/>
-              <a:ln w="28440">
-                <a:solidFill>
-                  <a:schemeClr val="accent1"/>
-                </a:solidFill>
-                <a:round/>
-              </a:ln>
-            </p:spPr>
-            <p:style>
-              <a:lnRef idx="0"/>
-              <a:fillRef idx="0"/>
-              <a:effectRef idx="0"/>
-              <a:fontRef idx="minor"/>
-            </p:style>
-            <p:txBody>
-              <a:bodyPr lIns="90000" rIns="90000" tIns="-35640" bIns="-35640" anchor="t">
-                <a:noAutofit/>
-              </a:bodyPr>
-              <a:p>
-                <a:endParaRPr b="0" lang="en-GB" sz="1800" spc="-1" strike="noStrike">
-                  <a:solidFill>
-                    <a:srgbClr val="000000"/>
-                  </a:solidFill>
-                  <a:latin typeface="Arial"/>
-                </a:endParaRPr>
-              </a:p>
-            </p:txBody>
-          </p:sp>
-          <p:sp>
-            <p:nvSpPr>
-              <p:cNvPr id="233" name="Freeform 49"/>
-              <p:cNvSpPr/>
-              <p:nvPr/>
-            </p:nvSpPr>
-            <p:spPr>
-              <a:xfrm>
-                <a:off x="6734160" y="5238720"/>
-                <a:ext cx="171000" cy="128160"/>
-              </a:xfrm>
-              <a:custGeom>
-                <a:avLst/>
-                <a:gdLst>
-                  <a:gd name="textAreaLeft" fmla="*/ 0 w 171000"/>
-                  <a:gd name="textAreaRight" fmla="*/ 171360 w 171000"/>
-                  <a:gd name="textAreaTop" fmla="*/ 0 h 128160"/>
-                  <a:gd name="textAreaBottom" fmla="*/ 128520 h 128160"/>
-                </a:gdLst>
-                <a:ahLst/>
-                <a:rect l="textAreaLeft" t="textAreaTop" r="textAreaRight" b="textAreaBottom"/>
-                <a:pathLst>
-                  <a:path w="171450" h="128588">
-                    <a:moveTo>
-                      <a:pt x="0" y="114300"/>
-                    </a:moveTo>
-                    <a:lnTo>
-                      <a:pt x="0" y="85725"/>
-                    </a:lnTo>
-                    <a:cubicBezTo>
-                      <a:pt x="0" y="38380"/>
-                      <a:pt x="38380" y="0"/>
-                      <a:pt x="85725" y="0"/>
-                    </a:cubicBezTo>
-                    <a:cubicBezTo>
-                      <a:pt x="133070" y="0"/>
-                      <a:pt x="171450" y="38380"/>
-                      <a:pt x="171450" y="85725"/>
-                    </a:cubicBezTo>
-                    <a:lnTo>
-                      <a:pt x="171450" y="114300"/>
-                    </a:lnTo>
-                    <a:cubicBezTo>
-                      <a:pt x="171450" y="122191"/>
-                      <a:pt x="165053" y="128588"/>
-                      <a:pt x="157162" y="128588"/>
-                    </a:cubicBezTo>
-                    <a:lnTo>
-                      <a:pt x="14288" y="128588"/>
-                    </a:lnTo>
-                    <a:cubicBezTo>
-                      <a:pt x="6397" y="128588"/>
-                      <a:pt x="0" y="122191"/>
-                      <a:pt x="0" y="114300"/>
-                    </a:cubicBezTo>
-                  </a:path>
-                </a:pathLst>
-              </a:custGeom>
-              <a:noFill/>
-              <a:ln w="28440">
-                <a:solidFill>
-                  <a:schemeClr val="accent1"/>
-                </a:solidFill>
-                <a:round/>
-              </a:ln>
-            </p:spPr>
-            <p:style>
-              <a:lnRef idx="0"/>
-              <a:fillRef idx="0"/>
-              <a:effectRef idx="0"/>
-              <a:fontRef idx="minor"/>
-            </p:style>
-            <p:txBody>
-              <a:bodyPr lIns="90000" rIns="90000" tIns="45000" bIns="45000" anchor="t">
-                <a:noAutofit/>
-              </a:bodyPr>
-              <a:p>
-                <a:endParaRPr b="0" lang="en-GB" sz="1800" spc="-1" strike="noStrike">
-                  <a:solidFill>
-                    <a:srgbClr val="000000"/>
-                  </a:solidFill>
-                  <a:latin typeface="Arial"/>
-                </a:endParaRPr>
-              </a:p>
-            </p:txBody>
-          </p:sp>
-          <p:sp>
-            <p:nvSpPr>
-              <p:cNvPr id="234" name="Freeform 50"/>
-              <p:cNvSpPr/>
-              <p:nvPr/>
-            </p:nvSpPr>
-            <p:spPr>
-              <a:xfrm>
-                <a:off x="6734160" y="5110200"/>
-                <a:ext cx="171000" cy="128160"/>
-              </a:xfrm>
-              <a:custGeom>
-                <a:avLst/>
-                <a:gdLst>
-                  <a:gd name="textAreaLeft" fmla="*/ 0 w 171000"/>
-                  <a:gd name="textAreaRight" fmla="*/ 171360 w 171000"/>
-                  <a:gd name="textAreaTop" fmla="*/ 0 h 128160"/>
-                  <a:gd name="textAreaBottom" fmla="*/ 128520 h 128160"/>
-                </a:gdLst>
-                <a:ahLst/>
-                <a:rect l="textAreaLeft" t="textAreaTop" r="textAreaRight" b="textAreaBottom"/>
-                <a:pathLst>
-                  <a:path w="171450" h="128588">
-                    <a:moveTo>
-                      <a:pt x="0" y="14288"/>
-                    </a:moveTo>
-                    <a:lnTo>
-                      <a:pt x="0" y="42862"/>
-                    </a:lnTo>
-                    <a:cubicBezTo>
-                      <a:pt x="0" y="90207"/>
-                      <a:pt x="38380" y="128588"/>
-                      <a:pt x="85725" y="128588"/>
-                    </a:cubicBezTo>
-                    <a:cubicBezTo>
-                      <a:pt x="133070" y="128588"/>
-                      <a:pt x="171450" y="90207"/>
-                      <a:pt x="171450" y="42862"/>
-                    </a:cubicBezTo>
-                    <a:lnTo>
-                      <a:pt x="171450" y="14288"/>
-                    </a:lnTo>
-                    <a:cubicBezTo>
-                      <a:pt x="171450" y="6397"/>
-                      <a:pt x="165053" y="0"/>
-                      <a:pt x="157162" y="0"/>
-                    </a:cubicBezTo>
-                    <a:lnTo>
-                      <a:pt x="14288" y="0"/>
-                    </a:lnTo>
-                    <a:cubicBezTo>
-                      <a:pt x="6397" y="0"/>
-                      <a:pt x="0" y="6397"/>
-                      <a:pt x="0" y="14288"/>
-                    </a:cubicBezTo>
-                  </a:path>
-                </a:pathLst>
-              </a:custGeom>
-              <a:noFill/>
-              <a:ln w="28440">
-                <a:solidFill>
-                  <a:schemeClr val="accent1"/>
-                </a:solidFill>
-                <a:round/>
-              </a:ln>
-            </p:spPr>
-            <p:style>
-              <a:lnRef idx="0"/>
-              <a:fillRef idx="0"/>
-              <a:effectRef idx="0"/>
-              <a:fontRef idx="minor"/>
-            </p:style>
-            <p:txBody>
-              <a:bodyPr lIns="90000" rIns="90000" tIns="45000" bIns="45000" anchor="t">
-                <a:noAutofit/>
-              </a:bodyPr>
-              <a:p>
-                <a:endParaRPr b="0" lang="en-GB" sz="1800" spc="-1" strike="noStrike">
-                  <a:solidFill>
-                    <a:srgbClr val="000000"/>
-                  </a:solidFill>
-                  <a:latin typeface="Arial"/>
-                </a:endParaRPr>
-              </a:p>
-            </p:txBody>
-          </p:sp>
-        </p:grpSp>
-        <p:sp>
-          <p:nvSpPr>
-            <p:cNvPr id="235" name="TextBox 52"/>
-            <p:cNvSpPr/>
-            <p:nvPr/>
-          </p:nvSpPr>
-          <p:spPr>
-            <a:xfrm>
-              <a:off x="7281360" y="5067360"/>
-              <a:ext cx="4019760" cy="343440"/>
-            </a:xfrm>
-            <a:prstGeom prst="rect">
-              <a:avLst/>
-            </a:prstGeom>
-            <a:noFill/>
-            <a:ln w="0">
-              <a:noFill/>
-            </a:ln>
-          </p:spPr>
-          <p:style>
-            <a:lnRef idx="0"/>
-            <a:fillRef idx="0"/>
-            <a:effectRef idx="0"/>
-            <a:fontRef idx="minor"/>
-          </p:style>
-          <p:txBody>
-            <a:bodyPr wrap="none" lIns="0" rIns="0" tIns="0" bIns="0" anchor="t">
-              <a:spAutoFit/>
-            </a:bodyPr>
-            <a:p>
-              <a:pPr defTabSz="457200">
-                <a:lnSpc>
-                  <a:spcPct val="100000"/>
-                </a:lnSpc>
-              </a:pPr>
-              <a:r>
-                <a:rPr b="1" lang="en-GB" sz="2250" spc="-1" strike="noStrike">
-                  <a:solidFill>
-                    <a:schemeClr val="dk1"/>
-                  </a:solidFill>
-                  <a:latin typeface="Aptos"/>
-                  <a:ea typeface="Microsoft YaHei"/>
-                </a:rPr>
-                <a:t>PBE0 calculation in progress</a:t>
-              </a:r>
-              <a:endParaRPr b="0" lang="en-GB" sz="2250" spc="-1" strike="noStrike">
-                <a:solidFill>
-                  <a:srgbClr val="000000"/>
-                </a:solidFill>
-                <a:latin typeface="Arial"/>
-              </a:endParaRPr>
-            </a:p>
-          </p:txBody>
-        </p:sp>
-      </p:grpSp>
-      <p:grpSp>
-        <p:nvGrpSpPr>
-          <p:cNvPr id="236" name="credits"/>
+          <p:cNvPr id="247" name="credits"/>
           <p:cNvGrpSpPr/>
           <p:nvPr/>
         </p:nvGrpSpPr>
@@ -13117,7 +13662,7 @@
         </p:grpSpPr>
         <p:sp>
           <p:nvSpPr>
-            <p:cNvPr id="237" name="Line 54"/>
+            <p:cNvPr id="248" name="Line 54"/>
             <p:cNvSpPr/>
             <p:nvPr/>
           </p:nvSpPr>
@@ -13177,7 +13722,7 @@
         </p:sp>
         <p:sp>
           <p:nvSpPr>
-            <p:cNvPr id="238" name="Freeform 55"/>
+            <p:cNvPr id="249" name="Freeform 55"/>
             <p:cNvSpPr/>
             <p:nvPr/>
           </p:nvSpPr>
@@ -13358,7 +13903,7 @@
         </p:sp>
         <p:sp>
           <p:nvSpPr>
-            <p:cNvPr id="239" name="TextBox 56"/>
+            <p:cNvPr id="250" name="TextBox 56"/>
             <p:cNvSpPr/>
             <p:nvPr/>
           </p:nvSpPr>
@@ -13414,7 +13959,7 @@
         </p:sp>
         <p:sp>
           <p:nvSpPr>
-            <p:cNvPr id="240" name="TextBox 57"/>
+            <p:cNvPr id="251" name="TextBox 57"/>
             <p:cNvSpPr/>
             <p:nvPr/>
           </p:nvSpPr>
@@ -13515,7 +14060,7 @@
                                           </p:stCondLst>
                                         </p:cTn>
                                         <p:tgtEl>
-                                          <p:spTgt spid="228"/>
+                                          <p:spTgt spid="247"/>
                                         </p:tgtEl>
                                         <p:attrNameLst>
                                           <p:attrName>style.visibility</p:attrName>
@@ -13529,60 +14074,7 @@
                                       <p:cBhvr additive="repl">
                                         <p:cTn id="46" dur="500"/>
                                         <p:tgtEl>
-                                          <p:spTgt spid="228"/>
-                                        </p:tgtEl>
-                                      </p:cBhvr>
-                                    </p:animEffect>
-                                  </p:childTnLst>
-                                </p:cTn>
-                              </p:par>
-                            </p:childTnLst>
-                          </p:cTn>
-                        </p:par>
-                      </p:childTnLst>
-                    </p:cTn>
-                  </p:par>
-                  <p:par>
-                    <p:cTn id="47" fill="hold">
-                      <p:stCondLst>
-                        <p:cond delay="indefinite"/>
-                      </p:stCondLst>
-                      <p:childTnLst>
-                        <p:par>
-                          <p:cTn id="48" fill="hold">
-                            <p:stCondLst>
-                              <p:cond delay="0"/>
-                            </p:stCondLst>
-                            <p:childTnLst>
-                              <p:par>
-                                <p:cTn id="49" nodeType="clickEffect" fill="hold" presetClass="entr" presetID="10">
-                                  <p:stCondLst>
-                                    <p:cond delay="0"/>
-                                  </p:stCondLst>
-                                  <p:childTnLst>
-                                    <p:set>
-                                      <p:cBhvr>
-                                        <p:cTn id="50" dur="1" fill="hold">
-                                          <p:stCondLst>
-                                            <p:cond delay="0"/>
-                                          </p:stCondLst>
-                                        </p:cTn>
-                                        <p:tgtEl>
-                                          <p:spTgt spid="236"/>
-                                        </p:tgtEl>
-                                        <p:attrNameLst>
-                                          <p:attrName>style.visibility</p:attrName>
-                                        </p:attrNameLst>
-                                      </p:cBhvr>
-                                      <p:to>
-                                        <p:strVal val="visible"/>
-                                      </p:to>
-                                    </p:set>
-                                    <p:animEffect filter="fade" transition="in">
-                                      <p:cBhvr additive="repl">
-                                        <p:cTn id="51" dur="500"/>
-                                        <p:tgtEl>
-                                          <p:spTgt spid="236"/>
+                                          <p:spTgt spid="247"/>
                                         </p:tgtEl>
                                       </p:cBhvr>
                                     </p:animEffect>

</xml_diff>